<commit_message>
feat: rm old links
</commit_message>
<xml_diff>
--- a/chapter-1/материалы по гиту.pptx
+++ b/chapter-1/материалы по гиту.pptx
@@ -5,7 +5,7 @@
     <p:sldMasterId id="2147483660" r:id="rId1"/>
   </p:sldMasterIdLst>
   <p:notesMasterIdLst>
-    <p:notesMasterId r:id="rId14"/>
+    <p:notesMasterId r:id="rId13"/>
   </p:notesMasterIdLst>
   <p:sldIdLst>
     <p:sldId id="256" r:id="rId2"/>
@@ -13,38 +13,37 @@
     <p:sldId id="278" r:id="rId4"/>
     <p:sldId id="279" r:id="rId5"/>
     <p:sldId id="282" r:id="rId6"/>
-    <p:sldId id="283" r:id="rId7"/>
-    <p:sldId id="285" r:id="rId8"/>
-    <p:sldId id="286" r:id="rId9"/>
-    <p:sldId id="280" r:id="rId10"/>
-    <p:sldId id="281" r:id="rId11"/>
+    <p:sldId id="285" r:id="rId7"/>
+    <p:sldId id="283" r:id="rId8"/>
+    <p:sldId id="280" r:id="rId9"/>
+    <p:sldId id="281" r:id="rId10"/>
+    <p:sldId id="272" r:id="rId11"/>
     <p:sldId id="284" r:id="rId12"/>
-    <p:sldId id="272" r:id="rId13"/>
   </p:sldIdLst>
   <p:sldSz cx="24382413" cy="13716000"/>
   <p:notesSz cx="6858000" cy="9144000"/>
   <p:embeddedFontLst>
     <p:embeddedFont>
       <p:font typeface="Tahoma" panose="020B0604030504040204" pitchFamily="34" charset="0"/>
-      <p:regular r:id="rId15"/>
-      <p:bold r:id="rId16"/>
-      <p:italic r:id="rId17"/>
+      <p:regular r:id="rId14"/>
+      <p:bold r:id="rId15"/>
+      <p:italic r:id="rId16"/>
     </p:embeddedFont>
     <p:embeddedFont>
       <p:font typeface="TT Norms Pro" panose="020B0103030101020204" pitchFamily="34" charset="0"/>
-      <p:regular r:id="rId18"/>
-      <p:bold r:id="rId19"/>
-      <p:italic r:id="rId20"/>
-      <p:boldItalic r:id="rId21"/>
+      <p:regular r:id="rId17"/>
+      <p:bold r:id="rId18"/>
+      <p:italic r:id="rId19"/>
+      <p:boldItalic r:id="rId20"/>
     </p:embeddedFont>
     <p:embeddedFont>
       <p:font typeface="TT Norms Pro Medium" panose="020B0103030101020204" pitchFamily="34" charset="0"/>
-      <p:regular r:id="rId22"/>
-      <p:italic r:id="rId23"/>
+      <p:regular r:id="rId21"/>
+      <p:italic r:id="rId22"/>
     </p:embeddedFont>
   </p:embeddedFontLst>
   <p:custDataLst>
-    <p:tags r:id="rId24"/>
+    <p:tags r:id="rId23"/>
   </p:custDataLst>
   <p:defaultTextStyle>
     <a:defPPr>
@@ -256,7 +255,7 @@
           <a:p>
             <a:fld id="{92AE627D-15EB-40F5-AEC0-AD078B3D9203}" type="datetimeFigureOut">
               <a:rPr lang="ru-RU" smtClean="0"/>
-              <a:t>02.10.2024</a:t>
+              <a:t>27.09.2025</a:t>
             </a:fld>
             <a:endParaRPr lang="ru-RU"/>
           </a:p>
@@ -567,7 +566,7 @@
           <a:bodyPr/>
           <a:lstStyle/>
           <a:p>
-            <a:endParaRPr lang="ru-RU" dirty="0"/>
+            <a:endParaRPr lang="ru-RU"/>
           </a:p>
         </p:txBody>
       </p:sp>
@@ -588,7 +587,7 @@
           <a:p>
             <a:fld id="{C63FAC02-5901-4D7E-90A5-4DB54C8C6E87}" type="slidenum">
               <a:rPr lang="ru-RU" smtClean="0"/>
-              <a:t>9</a:t>
+              <a:t>1</a:t>
             </a:fld>
             <a:endParaRPr lang="ru-RU"/>
           </a:p>
@@ -597,7 +596,7 @@
     </p:spTree>
     <p:extLst>
       <p:ext uri="{BB962C8B-B14F-4D97-AF65-F5344CB8AC3E}">
-        <p14:creationId xmlns:p14="http://schemas.microsoft.com/office/powerpoint/2010/main" val="1937663396"/>
+        <p14:creationId xmlns:p14="http://schemas.microsoft.com/office/powerpoint/2010/main" val="2709643221"/>
       </p:ext>
     </p:extLst>
   </p:cSld>
@@ -672,7 +671,7 @@
           <a:p>
             <a:fld id="{C63FAC02-5901-4D7E-90A5-4DB54C8C6E87}" type="slidenum">
               <a:rPr lang="ru-RU" smtClean="0"/>
-              <a:t>10</a:t>
+              <a:t>8</a:t>
             </a:fld>
             <a:endParaRPr lang="ru-RU"/>
           </a:p>
@@ -681,7 +680,7 @@
     </p:spTree>
     <p:extLst>
       <p:ext uri="{BB962C8B-B14F-4D97-AF65-F5344CB8AC3E}">
-        <p14:creationId xmlns:p14="http://schemas.microsoft.com/office/powerpoint/2010/main" val="2635436792"/>
+        <p14:creationId xmlns:p14="http://schemas.microsoft.com/office/powerpoint/2010/main" val="1937663396"/>
       </p:ext>
     </p:extLst>
   </p:cSld>
@@ -756,7 +755,7 @@
           <a:p>
             <a:fld id="{C63FAC02-5901-4D7E-90A5-4DB54C8C6E87}" type="slidenum">
               <a:rPr lang="ru-RU" smtClean="0"/>
-              <a:t>11</a:t>
+              <a:t>9</a:t>
             </a:fld>
             <a:endParaRPr lang="ru-RU"/>
           </a:p>
@@ -765,7 +764,7 @@
     </p:spTree>
     <p:extLst>
       <p:ext uri="{BB962C8B-B14F-4D97-AF65-F5344CB8AC3E}">
-        <p14:creationId xmlns:p14="http://schemas.microsoft.com/office/powerpoint/2010/main" val="411072299"/>
+        <p14:creationId xmlns:p14="http://schemas.microsoft.com/office/powerpoint/2010/main" val="2635436792"/>
       </p:ext>
     </p:extLst>
   </p:cSld>
@@ -840,7 +839,7 @@
           <a:p>
             <a:fld id="{C63FAC02-5901-4D7E-90A5-4DB54C8C6E87}" type="slidenum">
               <a:rPr lang="ru-RU" smtClean="0"/>
-              <a:t>12</a:t>
+              <a:t>10</a:t>
             </a:fld>
             <a:endParaRPr lang="ru-RU"/>
           </a:p>
@@ -850,6 +849,90 @@
     <p:extLst>
       <p:ext uri="{BB962C8B-B14F-4D97-AF65-F5344CB8AC3E}">
         <p14:creationId xmlns:p14="http://schemas.microsoft.com/office/powerpoint/2010/main" val="371541482"/>
+      </p:ext>
+    </p:extLst>
+  </p:cSld>
+  <p:clrMapOvr>
+    <a:masterClrMapping/>
+  </p:clrMapOvr>
+</p:notes>
+</file>
+
+<file path=ppt/notesSlides/notesSlide5.xml><?xml version="1.0" encoding="utf-8"?>
+<p:notes xmlns:a="http://schemas.openxmlformats.org/drawingml/2006/main" xmlns:r="http://schemas.openxmlformats.org/officeDocument/2006/relationships" xmlns:p="http://schemas.openxmlformats.org/presentationml/2006/main">
+  <p:cSld>
+    <p:spTree>
+      <p:nvGrpSpPr>
+        <p:cNvPr id="1" name=""/>
+        <p:cNvGrpSpPr/>
+        <p:nvPr/>
+      </p:nvGrpSpPr>
+      <p:grpSpPr>
+        <a:xfrm>
+          <a:off x="0" y="0"/>
+          <a:ext cx="0" cy="0"/>
+          <a:chOff x="0" y="0"/>
+          <a:chExt cx="0" cy="0"/>
+        </a:xfrm>
+      </p:grpSpPr>
+      <p:sp>
+        <p:nvSpPr>
+          <p:cNvPr id="2" name="Образ слайда 1"/>
+          <p:cNvSpPr>
+            <a:spLocks noGrp="1" noRot="1" noChangeAspect="1"/>
+          </p:cNvSpPr>
+          <p:nvPr>
+            <p:ph type="sldImg"/>
+          </p:nvPr>
+        </p:nvSpPr>
+        <p:spPr/>
+      </p:sp>
+      <p:sp>
+        <p:nvSpPr>
+          <p:cNvPr id="3" name="Заметки 2"/>
+          <p:cNvSpPr>
+            <a:spLocks noGrp="1"/>
+          </p:cNvSpPr>
+          <p:nvPr>
+            <p:ph type="body" idx="1"/>
+          </p:nvPr>
+        </p:nvSpPr>
+        <p:spPr/>
+        <p:txBody>
+          <a:bodyPr/>
+          <a:lstStyle/>
+          <a:p>
+            <a:endParaRPr lang="ru-RU" dirty="0"/>
+          </a:p>
+        </p:txBody>
+      </p:sp>
+      <p:sp>
+        <p:nvSpPr>
+          <p:cNvPr id="4" name="Номер слайда 3"/>
+          <p:cNvSpPr>
+            <a:spLocks noGrp="1"/>
+          </p:cNvSpPr>
+          <p:nvPr>
+            <p:ph type="sldNum" sz="quarter" idx="5"/>
+          </p:nvPr>
+        </p:nvSpPr>
+        <p:spPr/>
+        <p:txBody>
+          <a:bodyPr/>
+          <a:lstStyle/>
+          <a:p>
+            <a:fld id="{C63FAC02-5901-4D7E-90A5-4DB54C8C6E87}" type="slidenum">
+              <a:rPr lang="ru-RU" smtClean="0"/>
+              <a:t>11</a:t>
+            </a:fld>
+            <a:endParaRPr lang="ru-RU"/>
+          </a:p>
+        </p:txBody>
+      </p:sp>
+    </p:spTree>
+    <p:extLst>
+      <p:ext uri="{BB962C8B-B14F-4D97-AF65-F5344CB8AC3E}">
+        <p14:creationId xmlns:p14="http://schemas.microsoft.com/office/powerpoint/2010/main" val="411072299"/>
       </p:ext>
     </p:extLst>
   </p:cSld>
@@ -11942,7 +12025,7 @@
                 <a:ea typeface="Tahoma" panose="020B0604030504040204" pitchFamily="34" charset="0"/>
                 <a:cs typeface="Tahoma" panose="020B0604030504040204" pitchFamily="34" charset="0"/>
               </a:rPr>
-              <a:t>02.10.2024</a:t>
+              <a:t>27.09.2025</a:t>
             </a:r>
           </a:p>
         </p:txBody>
@@ -11979,7 +12062,7 @@
       </p:grpSpPr>
       <p:sp>
         <p:nvSpPr>
-          <p:cNvPr id="12" name="Заголовок 11"/>
+          <p:cNvPr id="7" name="Заголовок 6"/>
           <p:cNvSpPr>
             <a:spLocks noGrp="1"/>
           </p:cNvSpPr>
@@ -11987,496 +12070,26 @@
             <p:ph type="ctrTitle"/>
           </p:nvPr>
         </p:nvSpPr>
-        <p:spPr>
-          <a:xfrm>
-            <a:off x="1298515" y="2115691"/>
-            <a:ext cx="11888095" cy="1103759"/>
-          </a:xfrm>
-        </p:spPr>
+        <p:spPr/>
         <p:txBody>
           <a:bodyPr/>
           <a:lstStyle/>
           <a:p>
-            <a:r>
-              <a:rPr lang="en-US" sz="7200" b="1" dirty="0" err="1">
-                <a:latin typeface="Tahoma" panose="020B0604030504040204" pitchFamily="34" charset="0"/>
-                <a:ea typeface="Tahoma" panose="020B0604030504040204" pitchFamily="34" charset="0"/>
-                <a:cs typeface="Tahoma" panose="020B0604030504040204" pitchFamily="34" charset="0"/>
-              </a:rPr>
-              <a:t>К</a:t>
-            </a:r>
-            <a:r>
-              <a:rPr lang="ru-RU" sz="7200" b="1" dirty="0" err="1">
-                <a:latin typeface="Tahoma" panose="020B0604030504040204" pitchFamily="34" charset="0"/>
-                <a:ea typeface="Tahoma" panose="020B0604030504040204" pitchFamily="34" charset="0"/>
-                <a:cs typeface="Tahoma" panose="020B0604030504040204" pitchFamily="34" charset="0"/>
-              </a:rPr>
-              <a:t>оманды</a:t>
-            </a:r>
             <a:r>
               <a:rPr lang="ru-RU" sz="7200" b="1" dirty="0">
                 <a:latin typeface="Tahoma" panose="020B0604030504040204" pitchFamily="34" charset="0"/>
                 <a:ea typeface="Tahoma" panose="020B0604030504040204" pitchFamily="34" charset="0"/>
                 <a:cs typeface="Tahoma" panose="020B0604030504040204" pitchFamily="34" charset="0"/>
               </a:rPr>
-              <a:t> </a:t>
-            </a:r>
-            <a:r>
-              <a:rPr lang="en-US" sz="7200" b="1" dirty="0">
-                <a:latin typeface="Tahoma" panose="020B0604030504040204" pitchFamily="34" charset="0"/>
-                <a:ea typeface="Tahoma" panose="020B0604030504040204" pitchFamily="34" charset="0"/>
-                <a:cs typeface="Tahoma" panose="020B0604030504040204" pitchFamily="34" charset="0"/>
-              </a:rPr>
-              <a:t>git</a:t>
-            </a:r>
-            <a:endParaRPr lang="ru-RU" sz="7200" b="1" dirty="0">
-              <a:latin typeface="Tahoma" panose="020B0604030504040204" pitchFamily="34" charset="0"/>
-              <a:ea typeface="Tahoma" panose="020B0604030504040204" pitchFamily="34" charset="0"/>
-              <a:cs typeface="Tahoma" panose="020B0604030504040204" pitchFamily="34" charset="0"/>
-            </a:endParaRPr>
-          </a:p>
-        </p:txBody>
-      </p:sp>
-      <p:sp>
-        <p:nvSpPr>
-          <p:cNvPr id="14" name="Текст 13"/>
-          <p:cNvSpPr>
-            <a:spLocks noGrp="1"/>
-          </p:cNvSpPr>
-          <p:nvPr>
-            <p:ph type="body" sz="quarter" idx="12"/>
-          </p:nvPr>
-        </p:nvSpPr>
-        <p:spPr>
-          <a:xfrm>
-            <a:off x="2840663" y="3488970"/>
-            <a:ext cx="18701085" cy="8111339"/>
-          </a:xfrm>
-        </p:spPr>
-        <p:txBody>
-          <a:bodyPr/>
-          <a:lstStyle/>
-          <a:p>
-            <a:pPr marL="0" indent="0">
-              <a:buNone/>
-            </a:pPr>
-            <a:r>
-              <a:rPr lang="en" sz="3600" b="1" dirty="0">
-                <a:solidFill>
-                  <a:schemeClr val="tx1"/>
-                </a:solidFill>
-                <a:effectLst/>
-                <a:latin typeface="+mn-lt"/>
-                <a:cs typeface="Times New Roman" panose="02020603050405020304" pitchFamily="18" charset="0"/>
-              </a:rPr>
-              <a:t>git commit </a:t>
-            </a:r>
-            <a:r>
-              <a:rPr lang="en-US" sz="3600" b="1" dirty="0">
-                <a:solidFill>
-                  <a:schemeClr val="tx1"/>
-                </a:solidFill>
-                <a:effectLst/>
-                <a:latin typeface="+mn-lt"/>
-                <a:cs typeface="Times New Roman" panose="02020603050405020304" pitchFamily="18" charset="0"/>
-              </a:rPr>
-              <a:t>–m “commit comment”</a:t>
-            </a:r>
-            <a:endParaRPr lang="en" sz="3600" dirty="0">
-              <a:solidFill>
-                <a:schemeClr val="tx1"/>
-              </a:solidFill>
-              <a:effectLst/>
-              <a:latin typeface="+mn-lt"/>
-              <a:cs typeface="Times New Roman" panose="02020603050405020304" pitchFamily="18" charset="0"/>
-            </a:endParaRPr>
-          </a:p>
-          <a:p>
-            <a:pPr marL="0" indent="0">
-              <a:buNone/>
-            </a:pPr>
-            <a:r>
-              <a:rPr lang="ru-RU" sz="3600" dirty="0" err="1">
-                <a:solidFill>
-                  <a:schemeClr val="tx1"/>
-                </a:solidFill>
-                <a:effectLst/>
-                <a:latin typeface="+mn-lt"/>
-                <a:cs typeface="Times New Roman" panose="02020603050405020304" pitchFamily="18" charset="0"/>
-              </a:rPr>
-              <a:t>Коммитит</a:t>
-            </a:r>
-            <a:r>
-              <a:rPr lang="ru-RU" sz="3600" dirty="0">
-                <a:solidFill>
-                  <a:schemeClr val="tx1"/>
-                </a:solidFill>
-                <a:effectLst/>
-                <a:latin typeface="+mn-lt"/>
-                <a:cs typeface="Times New Roman" panose="02020603050405020304" pitchFamily="18" charset="0"/>
-              </a:rPr>
-              <a:t> добавленные </a:t>
-            </a:r>
-            <a:r>
-              <a:rPr lang="en" sz="3600" dirty="0">
-                <a:solidFill>
-                  <a:schemeClr val="tx1"/>
-                </a:solidFill>
-                <a:effectLst/>
-                <a:latin typeface="+mn-lt"/>
-                <a:cs typeface="Times New Roman" panose="02020603050405020304" pitchFamily="18" charset="0"/>
-              </a:rPr>
-              <a:t>git add </a:t>
-            </a:r>
-            <a:r>
-              <a:rPr lang="ru-RU" sz="3600" dirty="0" err="1">
-                <a:solidFill>
-                  <a:schemeClr val="tx1"/>
-                </a:solidFill>
-                <a:effectLst/>
-                <a:latin typeface="+mn-lt"/>
-                <a:cs typeface="Times New Roman" panose="02020603050405020304" pitchFamily="18" charset="0"/>
-              </a:rPr>
-              <a:t>файлы</a:t>
-            </a:r>
-            <a:r>
-              <a:rPr lang="ru-RU" sz="3600" dirty="0">
-                <a:solidFill>
-                  <a:schemeClr val="tx1"/>
-                </a:solidFill>
-                <a:effectLst/>
-                <a:latin typeface="+mn-lt"/>
-                <a:cs typeface="Times New Roman" panose="02020603050405020304" pitchFamily="18" charset="0"/>
-              </a:rPr>
-              <a:t> </a:t>
-            </a:r>
-          </a:p>
-          <a:p>
-            <a:pPr marL="0" indent="0">
-              <a:buNone/>
-            </a:pPr>
-            <a:r>
-              <a:rPr lang="ru-RU" sz="3600" dirty="0">
-                <a:solidFill>
-                  <a:schemeClr val="tx1"/>
-                </a:solidFill>
-                <a:effectLst/>
-                <a:latin typeface="+mn-lt"/>
-                <a:cs typeface="Times New Roman" panose="02020603050405020304" pitchFamily="18" charset="0"/>
-              </a:rPr>
-              <a:t>В пишется комментарий к </a:t>
-            </a:r>
-            <a:r>
-              <a:rPr lang="ru-RU" sz="3600" dirty="0" err="1">
-                <a:solidFill>
-                  <a:schemeClr val="tx1"/>
-                </a:solidFill>
-                <a:effectLst/>
-                <a:latin typeface="+mn-lt"/>
-                <a:cs typeface="Times New Roman" panose="02020603050405020304" pitchFamily="18" charset="0"/>
-              </a:rPr>
-              <a:t>коммиту</a:t>
-            </a:r>
-            <a:r>
-              <a:rPr lang="ru-RU" sz="3600" dirty="0">
-                <a:solidFill>
-                  <a:schemeClr val="tx1"/>
-                </a:solidFill>
-                <a:effectLst/>
-                <a:latin typeface="+mn-lt"/>
-                <a:cs typeface="Times New Roman" panose="02020603050405020304" pitchFamily="18" charset="0"/>
-              </a:rPr>
-              <a:t> </a:t>
-            </a:r>
-          </a:p>
-          <a:p>
-            <a:pPr marL="0" indent="0">
-              <a:buNone/>
-            </a:pPr>
-            <a:endParaRPr lang="en-US" sz="3600" dirty="0">
-              <a:solidFill>
-                <a:schemeClr val="tx1"/>
-              </a:solidFill>
-              <a:latin typeface="+mn-lt"/>
-              <a:ea typeface="Tahoma" panose="020B0604030504040204" pitchFamily="34" charset="0"/>
-              <a:cs typeface="Times New Roman" panose="02020603050405020304" pitchFamily="18" charset="0"/>
-            </a:endParaRPr>
-          </a:p>
-          <a:p>
-            <a:pPr marL="0" indent="0">
-              <a:buNone/>
-            </a:pPr>
-            <a:r>
-              <a:rPr lang="en" sz="3600" b="1" dirty="0">
-                <a:solidFill>
-                  <a:schemeClr val="tx1"/>
-                </a:solidFill>
-                <a:effectLst/>
-                <a:latin typeface="+mn-lt"/>
-                <a:cs typeface="Times New Roman" panose="02020603050405020304" pitchFamily="18" charset="0"/>
-              </a:rPr>
-              <a:t>git push  origin main</a:t>
-            </a:r>
-            <a:endParaRPr lang="en" sz="3600" dirty="0">
-              <a:solidFill>
-                <a:schemeClr val="tx1"/>
-              </a:solidFill>
-              <a:effectLst/>
-              <a:latin typeface="+mn-lt"/>
-              <a:cs typeface="Times New Roman" panose="02020603050405020304" pitchFamily="18" charset="0"/>
-            </a:endParaRPr>
-          </a:p>
-          <a:p>
-            <a:pPr marL="0" indent="0">
-              <a:buNone/>
-            </a:pPr>
-            <a:r>
-              <a:rPr lang="ru-RU" sz="3600" dirty="0">
-                <a:solidFill>
-                  <a:schemeClr val="tx1"/>
-                </a:solidFill>
-                <a:effectLst/>
-                <a:latin typeface="+mn-lt"/>
-                <a:cs typeface="Times New Roman" panose="02020603050405020304" pitchFamily="18" charset="0"/>
-              </a:rPr>
-              <a:t>Закидывает </a:t>
-            </a:r>
-            <a:r>
-              <a:rPr lang="ru-RU" sz="3600" dirty="0" err="1">
-                <a:solidFill>
-                  <a:schemeClr val="tx1"/>
-                </a:solidFill>
-                <a:effectLst/>
-                <a:latin typeface="+mn-lt"/>
-                <a:cs typeface="Times New Roman" panose="02020603050405020304" pitchFamily="18" charset="0"/>
-              </a:rPr>
-              <a:t>закомиченныи</a:t>
-            </a:r>
-            <a:r>
-              <a:rPr lang="ru-RU" sz="3600" dirty="0">
-                <a:solidFill>
-                  <a:schemeClr val="tx1"/>
-                </a:solidFill>
-                <a:effectLst/>
-                <a:latin typeface="+mn-lt"/>
-                <a:cs typeface="Times New Roman" panose="02020603050405020304" pitchFamily="18" charset="0"/>
-              </a:rPr>
-              <a:t>̆ код в </a:t>
-            </a:r>
-            <a:r>
-              <a:rPr lang="ru-RU" sz="3600" dirty="0" err="1">
-                <a:solidFill>
-                  <a:schemeClr val="tx1"/>
-                </a:solidFill>
-                <a:effectLst/>
-                <a:latin typeface="+mn-lt"/>
-                <a:cs typeface="Times New Roman" panose="02020603050405020304" pitchFamily="18" charset="0"/>
-              </a:rPr>
-              <a:t>репозитории</a:t>
-            </a:r>
-            <a:r>
-              <a:rPr lang="ru-RU" sz="3600" dirty="0">
-                <a:solidFill>
-                  <a:schemeClr val="tx1"/>
-                </a:solidFill>
-                <a:effectLst/>
-                <a:latin typeface="+mn-lt"/>
-                <a:cs typeface="Times New Roman" panose="02020603050405020304" pitchFamily="18" charset="0"/>
-              </a:rPr>
-              <a:t>̆. Сначала </a:t>
-            </a:r>
-            <a:r>
-              <a:rPr lang="ru-RU" sz="3600" dirty="0" err="1">
-                <a:solidFill>
-                  <a:schemeClr val="tx1"/>
-                </a:solidFill>
-                <a:effectLst/>
-                <a:latin typeface="+mn-lt"/>
-                <a:cs typeface="Times New Roman" panose="02020603050405020304" pitchFamily="18" charset="0"/>
-              </a:rPr>
-              <a:t>идёт</a:t>
-            </a:r>
-            <a:r>
-              <a:rPr lang="ru-RU" sz="3600" dirty="0">
-                <a:solidFill>
-                  <a:schemeClr val="tx1"/>
-                </a:solidFill>
-                <a:effectLst/>
-                <a:latin typeface="+mn-lt"/>
-                <a:cs typeface="Times New Roman" panose="02020603050405020304" pitchFamily="18" charset="0"/>
-              </a:rPr>
-              <a:t> место, куда вы пушите, а потом что вы пишите </a:t>
-            </a:r>
-            <a:endParaRPr lang="en-US" sz="3600" dirty="0">
-              <a:solidFill>
-                <a:schemeClr val="tx1"/>
-              </a:solidFill>
-              <a:effectLst/>
-              <a:latin typeface="+mn-lt"/>
-              <a:cs typeface="Times New Roman" panose="02020603050405020304" pitchFamily="18" charset="0"/>
-            </a:endParaRPr>
-          </a:p>
-          <a:p>
-            <a:pPr marL="0" indent="0">
-              <a:buNone/>
-            </a:pPr>
-            <a:endParaRPr lang="en-US" sz="3600" dirty="0">
-              <a:solidFill>
-                <a:schemeClr val="tx1"/>
-              </a:solidFill>
-              <a:latin typeface="+mn-lt"/>
-              <a:cs typeface="Times New Roman" panose="02020603050405020304" pitchFamily="18" charset="0"/>
-            </a:endParaRPr>
-          </a:p>
-          <a:p>
-            <a:pPr marL="0" indent="0">
-              <a:buNone/>
-            </a:pPr>
-            <a:r>
-              <a:rPr lang="en" sz="3600" b="1" dirty="0">
-                <a:solidFill>
-                  <a:schemeClr val="tx1"/>
-                </a:solidFill>
-                <a:effectLst/>
-                <a:latin typeface="+mn-lt"/>
-                <a:cs typeface="Times New Roman" panose="02020603050405020304" pitchFamily="18" charset="0"/>
-              </a:rPr>
-              <a:t>git pull </a:t>
-            </a:r>
-            <a:endParaRPr lang="en" sz="3600" dirty="0">
-              <a:solidFill>
-                <a:schemeClr val="tx1"/>
-              </a:solidFill>
-              <a:effectLst/>
-              <a:latin typeface="+mn-lt"/>
-              <a:cs typeface="Times New Roman" panose="02020603050405020304" pitchFamily="18" charset="0"/>
-            </a:endParaRPr>
-          </a:p>
-          <a:p>
-            <a:pPr marL="0" indent="0">
-              <a:buNone/>
-            </a:pPr>
-            <a:r>
-              <a:rPr lang="ru-RU" sz="3600" dirty="0">
-                <a:solidFill>
-                  <a:schemeClr val="tx1"/>
-                </a:solidFill>
-                <a:effectLst/>
-                <a:latin typeface="+mn-lt"/>
-                <a:cs typeface="Times New Roman" panose="02020603050405020304" pitchFamily="18" charset="0"/>
-              </a:rPr>
-              <a:t>Стягивает к вам последние изменения в общепринятом состоянии </a:t>
-            </a:r>
-            <a:r>
-              <a:rPr lang="ru-RU" sz="3600" dirty="0" err="1">
-                <a:solidFill>
-                  <a:schemeClr val="tx1"/>
-                </a:solidFill>
-                <a:effectLst/>
-                <a:latin typeface="+mn-lt"/>
-                <a:cs typeface="Times New Roman" panose="02020603050405020304" pitchFamily="18" charset="0"/>
-              </a:rPr>
-              <a:t>репозитория</a:t>
-            </a:r>
-            <a:r>
-              <a:rPr lang="ru-RU" sz="3600" dirty="0">
-                <a:solidFill>
-                  <a:schemeClr val="tx1"/>
-                </a:solidFill>
-                <a:effectLst/>
-                <a:latin typeface="+mn-lt"/>
-                <a:cs typeface="Times New Roman" panose="02020603050405020304" pitchFamily="18" charset="0"/>
-              </a:rPr>
-              <a:t> </a:t>
-            </a:r>
-          </a:p>
-          <a:p>
-            <a:pPr marL="0" indent="0">
-              <a:buNone/>
-            </a:pPr>
-            <a:r>
-              <a:rPr lang="en-US" sz="3600" dirty="0">
-                <a:solidFill>
-                  <a:schemeClr val="tx1"/>
-                </a:solidFill>
-                <a:effectLst/>
-                <a:latin typeface="+mn-lt"/>
-                <a:cs typeface="Times New Roman" panose="02020603050405020304" pitchFamily="18" charset="0"/>
-              </a:rPr>
-              <a:t>(</a:t>
-            </a:r>
-            <a:r>
-              <a:rPr lang="ru-RU" sz="3600" dirty="0">
-                <a:solidFill>
-                  <a:schemeClr val="tx1"/>
-                </a:solidFill>
-                <a:latin typeface="+mn-lt"/>
-                <a:cs typeface="Times New Roman" panose="02020603050405020304" pitchFamily="18" charset="0"/>
-              </a:rPr>
-              <a:t>* Б</a:t>
-            </a:r>
-            <a:r>
-              <a:rPr lang="ru-RU" sz="3600" dirty="0">
-                <a:solidFill>
-                  <a:schemeClr val="tx1"/>
-                </a:solidFill>
-                <a:effectLst/>
-                <a:latin typeface="+mn-lt"/>
-                <a:cs typeface="Times New Roman" panose="02020603050405020304" pitchFamily="18" charset="0"/>
-              </a:rPr>
-              <a:t>удьте внимательны!  Изменяет ваши файлы)</a:t>
-            </a:r>
-          </a:p>
-          <a:p>
-            <a:pPr marL="0" indent="0">
-              <a:buNone/>
-            </a:pPr>
-            <a:endParaRPr lang="ru-RU" sz="2000" dirty="0">
-              <a:solidFill>
-                <a:schemeClr val="tx1"/>
-              </a:solidFill>
-              <a:effectLst/>
-              <a:latin typeface="+mn-lt"/>
-            </a:endParaRPr>
-          </a:p>
-        </p:txBody>
-      </p:sp>
-      <p:sp>
-        <p:nvSpPr>
-          <p:cNvPr id="18" name="Номер слайда 17"/>
-          <p:cNvSpPr>
-            <a:spLocks noGrp="1"/>
-          </p:cNvSpPr>
-          <p:nvPr>
-            <p:ph type="sldNum" sz="quarter" idx="20"/>
-          </p:nvPr>
-        </p:nvSpPr>
-        <p:spPr/>
-        <p:txBody>
-          <a:bodyPr/>
-          <a:lstStyle/>
-          <a:p>
-            <a:fld id="{66B5E2A4-72D4-4DC4-9470-54C0EE06E412}" type="slidenum">
-              <a:rPr lang="ru-RU" smtClean="0">
-                <a:latin typeface="Tahoma" panose="020B0604030504040204" pitchFamily="34" charset="0"/>
-                <a:ea typeface="Tahoma" panose="020B0604030504040204" pitchFamily="34" charset="0"/>
-                <a:cs typeface="Tahoma" panose="020B0604030504040204" pitchFamily="34" charset="0"/>
-              </a:rPr>
-              <a:pPr/>
-              <a:t>10</a:t>
-            </a:fld>
-            <a:endParaRPr lang="ru-RU" dirty="0">
-              <a:latin typeface="Tahoma" panose="020B0604030504040204" pitchFamily="34" charset="0"/>
-              <a:ea typeface="Tahoma" panose="020B0604030504040204" pitchFamily="34" charset="0"/>
-              <a:cs typeface="Tahoma" panose="020B0604030504040204" pitchFamily="34" charset="0"/>
-            </a:endParaRPr>
+              <a:t>Ваши вопросы???</a:t>
+            </a:r>
           </a:p>
         </p:txBody>
       </p:sp>
     </p:spTree>
     <p:extLst>
       <p:ext uri="{BB962C8B-B14F-4D97-AF65-F5344CB8AC3E}">
-        <p14:creationId xmlns:p14="http://schemas.microsoft.com/office/powerpoint/2010/main" val="1326201710"/>
+        <p14:creationId xmlns:p14="http://schemas.microsoft.com/office/powerpoint/2010/main" val="2912671105"/>
       </p:ext>
     </p:extLst>
   </p:cSld>
@@ -12764,62 +12377,6 @@
     <p:extLst>
       <p:ext uri="{BB962C8B-B14F-4D97-AF65-F5344CB8AC3E}">
         <p14:creationId xmlns:p14="http://schemas.microsoft.com/office/powerpoint/2010/main" val="3270186203"/>
-      </p:ext>
-    </p:extLst>
-  </p:cSld>
-  <p:clrMapOvr>
-    <a:masterClrMapping/>
-  </p:clrMapOvr>
-</p:sld>
-</file>
-
-<file path=ppt/slides/slide12.xml><?xml version="1.0" encoding="utf-8"?>
-<p:sld xmlns:a="http://schemas.openxmlformats.org/drawingml/2006/main" xmlns:r="http://schemas.openxmlformats.org/officeDocument/2006/relationships" xmlns:p="http://schemas.openxmlformats.org/presentationml/2006/main">
-  <p:cSld>
-    <p:spTree>
-      <p:nvGrpSpPr>
-        <p:cNvPr id="1" name=""/>
-        <p:cNvGrpSpPr/>
-        <p:nvPr/>
-      </p:nvGrpSpPr>
-      <p:grpSpPr>
-        <a:xfrm>
-          <a:off x="0" y="0"/>
-          <a:ext cx="0" cy="0"/>
-          <a:chOff x="0" y="0"/>
-          <a:chExt cx="0" cy="0"/>
-        </a:xfrm>
-      </p:grpSpPr>
-      <p:sp>
-        <p:nvSpPr>
-          <p:cNvPr id="7" name="Заголовок 6"/>
-          <p:cNvSpPr>
-            <a:spLocks noGrp="1"/>
-          </p:cNvSpPr>
-          <p:nvPr>
-            <p:ph type="ctrTitle"/>
-          </p:nvPr>
-        </p:nvSpPr>
-        <p:spPr/>
-        <p:txBody>
-          <a:bodyPr/>
-          <a:lstStyle/>
-          <a:p>
-            <a:r>
-              <a:rPr lang="ru-RU" sz="7200" b="1" dirty="0">
-                <a:latin typeface="Tahoma" panose="020B0604030504040204" pitchFamily="34" charset="0"/>
-                <a:ea typeface="Tahoma" panose="020B0604030504040204" pitchFamily="34" charset="0"/>
-                <a:cs typeface="Tahoma" panose="020B0604030504040204" pitchFamily="34" charset="0"/>
-              </a:rPr>
-              <a:t>Ваши вопросы???</a:t>
-            </a:r>
-          </a:p>
-        </p:txBody>
-      </p:sp>
-    </p:spTree>
-    <p:extLst>
-      <p:ext uri="{BB962C8B-B14F-4D97-AF65-F5344CB8AC3E}">
-        <p14:creationId xmlns:p14="http://schemas.microsoft.com/office/powerpoint/2010/main" val="2912671105"/>
       </p:ext>
     </p:extLst>
   </p:cSld>
@@ -14298,26 +13855,29 @@
           <a:lstStyle/>
           <a:p>
             <a:r>
+              <a:rPr lang="en-US" sz="7200" b="1" dirty="0" err="1">
+                <a:latin typeface="Tahoma" panose="020B0604030504040204" pitchFamily="34" charset="0"/>
+                <a:ea typeface="Tahoma" panose="020B0604030504040204" pitchFamily="34" charset="0"/>
+                <a:cs typeface="Tahoma" panose="020B0604030504040204" pitchFamily="34" charset="0"/>
+              </a:rPr>
+              <a:t>Ко</a:t>
+            </a:r>
+            <a:r>
+              <a:rPr lang="ru-RU" sz="7200" b="1" dirty="0" err="1">
+                <a:latin typeface="Tahoma" panose="020B0604030504040204" pitchFamily="34" charset="0"/>
+                <a:ea typeface="Tahoma" panose="020B0604030504040204" pitchFamily="34" charset="0"/>
+                <a:cs typeface="Tahoma" panose="020B0604030504040204" pitchFamily="34" charset="0"/>
+              </a:rPr>
+              <a:t>нцепция</a:t>
+            </a:r>
+            <a:r>
               <a:rPr lang="ru-RU" sz="7200" b="1" dirty="0">
                 <a:latin typeface="Tahoma" panose="020B0604030504040204" pitchFamily="34" charset="0"/>
                 <a:ea typeface="Tahoma" panose="020B0604030504040204" pitchFamily="34" charset="0"/>
                 <a:cs typeface="Tahoma" panose="020B0604030504040204" pitchFamily="34" charset="0"/>
               </a:rPr>
-              <a:t>Статус </a:t>
-            </a:r>
-            <a:r>
-              <a:rPr lang="ru-RU" sz="7200" b="1" dirty="0" err="1">
-                <a:latin typeface="Tahoma" panose="020B0604030504040204" pitchFamily="34" charset="0"/>
-                <a:ea typeface="Tahoma" panose="020B0604030504040204" pitchFamily="34" charset="0"/>
-                <a:cs typeface="Tahoma" panose="020B0604030504040204" pitchFamily="34" charset="0"/>
-              </a:rPr>
-              <a:t>репозитория</a:t>
-            </a:r>
-            <a:endParaRPr lang="ru-RU" sz="7200" b="1" dirty="0">
-              <a:latin typeface="Tahoma" panose="020B0604030504040204" pitchFamily="34" charset="0"/>
-              <a:ea typeface="Tahoma" panose="020B0604030504040204" pitchFamily="34" charset="0"/>
-              <a:cs typeface="Tahoma" panose="020B0604030504040204" pitchFamily="34" charset="0"/>
-            </a:endParaRPr>
+              <a:t> веток</a:t>
+            </a:r>
           </a:p>
         </p:txBody>
       </p:sp>
@@ -14346,13 +13906,192 @@
               <a:buNone/>
             </a:pPr>
             <a:r>
+              <a:rPr lang="ru-RU" sz="3600" b="1" dirty="0">
+                <a:solidFill>
+                  <a:schemeClr val="tx1"/>
+                </a:solidFill>
+                <a:latin typeface="+mn-lt"/>
+              </a:rPr>
+              <a:t>Ветки</a:t>
+            </a:r>
+            <a:r>
+              <a:rPr lang="ru-RU" sz="3600" dirty="0">
+                <a:solidFill>
+                  <a:schemeClr val="tx1"/>
+                </a:solidFill>
+                <a:latin typeface="+mn-lt"/>
+              </a:rPr>
+              <a:t> - </a:t>
+            </a:r>
+            <a:r>
+              <a:rPr lang="ru-RU" sz="3600" dirty="0">
+                <a:solidFill>
+                  <a:schemeClr val="tx1"/>
+                </a:solidFill>
+                <a:effectLst/>
+                <a:latin typeface="+mn-lt"/>
+              </a:rPr>
+              <a:t>это инструмент для </a:t>
+            </a:r>
+            <a:r>
+              <a:rPr lang="ru-RU" sz="3600" dirty="0" err="1">
+                <a:solidFill>
+                  <a:schemeClr val="tx1"/>
+                </a:solidFill>
+                <a:effectLst/>
+                <a:latin typeface="+mn-lt"/>
+              </a:rPr>
+              <a:t>команднои</a:t>
+            </a:r>
+            <a:r>
+              <a:rPr lang="ru-RU" sz="3600" dirty="0">
+                <a:solidFill>
+                  <a:schemeClr val="tx1"/>
+                </a:solidFill>
+                <a:effectLst/>
+                <a:latin typeface="+mn-lt"/>
+              </a:rPr>
+              <a:t>̆ работы в гите. Создавая ветвь, мы получаем параллельную вселенную, где сначала всё так же, как в </a:t>
+            </a:r>
+            <a:r>
+              <a:rPr lang="ru-RU" sz="3600" dirty="0" err="1">
+                <a:solidFill>
+                  <a:schemeClr val="tx1"/>
+                </a:solidFill>
+                <a:effectLst/>
+                <a:latin typeface="+mn-lt"/>
+              </a:rPr>
+              <a:t>основнои</a:t>
+            </a:r>
+            <a:r>
+              <a:rPr lang="ru-RU" sz="3600" dirty="0">
+                <a:solidFill>
+                  <a:schemeClr val="tx1"/>
+                </a:solidFill>
+                <a:effectLst/>
+                <a:latin typeface="+mn-lt"/>
+              </a:rPr>
+              <a:t>̆ ветке </a:t>
+            </a:r>
+            <a:r>
+              <a:rPr lang="en" sz="3600" dirty="0">
+                <a:solidFill>
+                  <a:schemeClr val="tx1"/>
+                </a:solidFill>
+                <a:effectLst/>
+                <a:latin typeface="+mn-lt"/>
+              </a:rPr>
+              <a:t>master. </a:t>
+            </a:r>
+            <a:r>
+              <a:rPr lang="ru-RU" sz="3600" dirty="0">
+                <a:solidFill>
+                  <a:schemeClr val="tx1"/>
+                </a:solidFill>
+                <a:effectLst/>
+                <a:latin typeface="+mn-lt"/>
+              </a:rPr>
+              <a:t>Меняя код в </a:t>
+            </a:r>
+            <a:r>
+              <a:rPr lang="ru-RU" sz="3600" dirty="0" err="1">
+                <a:solidFill>
+                  <a:schemeClr val="tx1"/>
+                </a:solidFill>
+                <a:effectLst/>
+                <a:latin typeface="+mn-lt"/>
+              </a:rPr>
+              <a:t>однои</a:t>
+            </a:r>
+            <a:r>
+              <a:rPr lang="ru-RU" sz="3600" dirty="0">
+                <a:solidFill>
+                  <a:schemeClr val="tx1"/>
+                </a:solidFill>
+                <a:effectLst/>
+                <a:latin typeface="+mn-lt"/>
+              </a:rPr>
+              <a:t>̆ ветке, состояние </a:t>
+            </a:r>
+            <a:r>
+              <a:rPr lang="ru-RU" sz="3600" dirty="0" err="1">
+                <a:solidFill>
+                  <a:schemeClr val="tx1"/>
+                </a:solidFill>
+                <a:effectLst/>
+                <a:latin typeface="+mn-lt"/>
+              </a:rPr>
+              <a:t>другои</a:t>
+            </a:r>
+            <a:r>
+              <a:rPr lang="ru-RU" sz="3600" dirty="0">
+                <a:solidFill>
+                  <a:schemeClr val="tx1"/>
+                </a:solidFill>
+                <a:effectLst/>
+                <a:latin typeface="+mn-lt"/>
+              </a:rPr>
+              <a:t>̆ </a:t>
+            </a:r>
+            <a:r>
+              <a:rPr lang="ru-RU" sz="3600" dirty="0" err="1">
+                <a:solidFill>
+                  <a:schemeClr val="tx1"/>
+                </a:solidFill>
+                <a:effectLst/>
+                <a:latin typeface="+mn-lt"/>
+              </a:rPr>
+              <a:t>остаётся</a:t>
+            </a:r>
+            <a:r>
+              <a:rPr lang="ru-RU" sz="3600" dirty="0">
+                <a:solidFill>
+                  <a:schemeClr val="tx1"/>
+                </a:solidFill>
+                <a:effectLst/>
+                <a:latin typeface="+mn-lt"/>
+              </a:rPr>
+              <a:t> прежним, то есть ветки могут развиваться независимо друг от друга </a:t>
+            </a:r>
+          </a:p>
+          <a:p>
+            <a:pPr marL="0" indent="0" algn="just">
+              <a:buNone/>
+            </a:pPr>
+            <a:endParaRPr lang="ru-RU" sz="2000" dirty="0">
+              <a:effectLst/>
+            </a:endParaRPr>
+          </a:p>
+          <a:p>
+            <a:pPr marL="0" indent="0" algn="just">
+              <a:buNone/>
+            </a:pPr>
+            <a:r>
+              <a:rPr lang="ru-RU" sz="3600" dirty="0">
+                <a:solidFill>
+                  <a:schemeClr val="tx1"/>
+                </a:solidFill>
+                <a:latin typeface="+mn-lt"/>
+              </a:rPr>
+              <a:t> </a:t>
+            </a:r>
+            <a:r>
+              <a:rPr lang="ru-RU" sz="3600" b="1" dirty="0" err="1">
+                <a:solidFill>
+                  <a:schemeClr val="tx1"/>
+                </a:solidFill>
+                <a:latin typeface="+mn-lt"/>
+              </a:rPr>
+              <a:t>g</a:t>
+            </a:r>
+            <a:r>
               <a:rPr lang="en-US" sz="3600" b="1" dirty="0">
                 <a:solidFill>
                   <a:schemeClr val="tx1"/>
                 </a:solidFill>
                 <a:latin typeface="+mn-lt"/>
               </a:rPr>
-              <a:t>git status </a:t>
+              <a:t>it branch </a:t>
             </a:r>
             <a:r>
               <a:rPr lang="en-US" sz="3600" dirty="0">
@@ -14361,7 +14100,7 @@
                 </a:solidFill>
                 <a:latin typeface="+mn-lt"/>
               </a:rPr>
-              <a:t>– </a:t>
+              <a:t>-&gt; </a:t>
             </a:r>
             <a:r>
               <a:rPr lang="ru-RU" sz="3600" dirty="0">
@@ -14370,23 +14109,44 @@
                 </a:solidFill>
                 <a:latin typeface="+mn-lt"/>
               </a:rPr>
-              <a:t>позволяет узнать текущее состоянии </a:t>
-            </a:r>
-            <a:r>
-              <a:rPr lang="ru-RU" sz="3600" dirty="0" err="1">
-                <a:solidFill>
-                  <a:schemeClr val="tx1"/>
-                </a:solidFill>
-                <a:latin typeface="+mn-lt"/>
-              </a:rPr>
-              <a:t>репозитория</a:t>
-            </a:r>
-            <a:endParaRPr lang="en-US" sz="3600" dirty="0">
-              <a:solidFill>
-                <a:schemeClr val="tx1"/>
-              </a:solidFill>
-              <a:latin typeface="+mn-lt"/>
-            </a:endParaRPr>
+              <a:t>покажет список всех веток и рядом с </a:t>
+            </a:r>
+            <a:r>
+              <a:rPr lang="en-US" sz="3600" dirty="0">
+                <a:solidFill>
+                  <a:schemeClr val="tx1"/>
+                </a:solidFill>
+                <a:latin typeface="+mn-lt"/>
+              </a:rPr>
+              <a:t>“</a:t>
+            </a:r>
+            <a:r>
+              <a:rPr lang="ru-RU" sz="3600" dirty="0">
+                <a:solidFill>
+                  <a:schemeClr val="tx1"/>
+                </a:solidFill>
+                <a:latin typeface="+mn-lt"/>
+              </a:rPr>
+              <a:t>*</a:t>
+            </a:r>
+            <a:r>
+              <a:rPr lang="en-US" sz="3600" dirty="0">
+                <a:solidFill>
+                  <a:schemeClr val="tx1"/>
+                </a:solidFill>
+                <a:latin typeface="+mn-lt"/>
+              </a:rPr>
+              <a:t>”</a:t>
+            </a:r>
+            <a:r>
+              <a:rPr lang="ru-RU" sz="3600" dirty="0">
+                <a:solidFill>
+                  <a:schemeClr val="tx1"/>
+                </a:solidFill>
+                <a:latin typeface="+mn-lt"/>
+              </a:rPr>
+              <a:t> ту, в которой вы находитесь</a:t>
+            </a:r>
           </a:p>
           <a:p>
             <a:pPr marL="0" indent="0" algn="just">
@@ -14403,25 +14163,69 @@
             <a:pPr marL="0" indent="0" algn="just">
               <a:buNone/>
             </a:pPr>
-            <a:endParaRPr lang="en-US" sz="3600" dirty="0">
-              <a:solidFill>
-                <a:schemeClr val="tx1"/>
-              </a:solidFill>
-              <a:latin typeface="+mn-lt"/>
-            </a:endParaRPr>
+            <a:r>
+              <a:rPr lang="en" sz="3600" dirty="0">
+                <a:solidFill>
+                  <a:schemeClr val="tx1"/>
+                </a:solidFill>
+                <a:latin typeface="+mn-lt"/>
+              </a:rPr>
+              <a:t> </a:t>
+            </a:r>
+            <a:r>
+              <a:rPr lang="en" sz="3600" b="1" dirty="0">
+                <a:solidFill>
+                  <a:schemeClr val="tx1"/>
+                </a:solidFill>
+                <a:latin typeface="+mn-lt"/>
+              </a:rPr>
+              <a:t>git branch &lt;name&gt; </a:t>
+            </a:r>
+            <a:r>
+              <a:rPr lang="ru-RU" sz="3600" dirty="0">
+                <a:solidFill>
+                  <a:schemeClr val="tx1"/>
+                </a:solidFill>
+                <a:latin typeface="+mn-lt"/>
+              </a:rPr>
+              <a:t>создаст новую ветку с именем </a:t>
+            </a:r>
+            <a:r>
+              <a:rPr lang="en-US" sz="3600" dirty="0">
+                <a:solidFill>
+                  <a:schemeClr val="tx1"/>
+                </a:solidFill>
+                <a:latin typeface="+mn-lt"/>
+              </a:rPr>
+              <a:t>name</a:t>
+            </a:r>
           </a:p>
           <a:p>
             <a:pPr marL="0" indent="0" algn="just">
               <a:buNone/>
             </a:pPr>
             <a:r>
-              <a:rPr lang="en" sz="3600" b="1" dirty="0">
-                <a:solidFill>
-                  <a:schemeClr val="tx1"/>
-                </a:solidFill>
-                <a:latin typeface="+mn-lt"/>
-              </a:rPr>
-              <a:t>g</a:t>
+              <a:rPr lang="en-US" sz="3600" dirty="0">
+                <a:solidFill>
+                  <a:schemeClr val="tx1"/>
+                </a:solidFill>
+                <a:latin typeface="+mn-lt"/>
+              </a:rPr>
+              <a:t> </a:t>
+            </a:r>
+          </a:p>
+          <a:p>
+            <a:pPr marL="0" indent="0" algn="just">
+              <a:buNone/>
+            </a:pPr>
+            <a:r>
+              <a:rPr lang="en-US" sz="3600" dirty="0">
+                <a:solidFill>
+                  <a:schemeClr val="tx1"/>
+                </a:solidFill>
+                <a:latin typeface="+mn-lt"/>
+              </a:rPr>
+              <a:t> </a:t>
             </a:r>
             <a:r>
               <a:rPr lang="en-US" sz="3600" b="1" dirty="0">
@@ -14430,16 +14234,7 @@
                 </a:solidFill>
                 <a:latin typeface="+mn-lt"/>
               </a:rPr>
-              <a:t>it log</a:t>
-            </a:r>
-            <a:r>
-              <a:rPr lang="ru-RU" sz="3600" b="1" dirty="0">
-                <a:solidFill>
-                  <a:schemeClr val="tx1"/>
-                </a:solidFill>
-                <a:latin typeface="+mn-lt"/>
-              </a:rPr>
-              <a:t> </a:t>
+              <a:t>git checkout &lt;name&gt; </a:t>
             </a:r>
             <a:r>
               <a:rPr lang="ru-RU" sz="3600" dirty="0">
@@ -14448,7 +14243,7 @@
                 </a:solidFill>
                 <a:latin typeface="+mn-lt"/>
               </a:rPr>
-              <a:t>- покажет всю историю </a:t>
+              <a:t>переключится на ветку с именем </a:t>
             </a:r>
             <a:r>
               <a:rPr lang="ru-RU" sz="3600" dirty="0" err="1">
@@ -14457,7 +14252,16 @@
                 </a:solidFill>
                 <a:latin typeface="+mn-lt"/>
               </a:rPr>
-              <a:t>коммитов</a:t>
+              <a:t>n</a:t>
+            </a:r>
+            <a:r>
+              <a:rPr lang="en-US" sz="3600" dirty="0" err="1">
+                <a:solidFill>
+                  <a:schemeClr val="tx1"/>
+                </a:solidFill>
+                <a:latin typeface="+mn-lt"/>
+              </a:rPr>
+              <a:t>ame</a:t>
             </a:r>
             <a:endParaRPr lang="ru-RU" sz="3600" dirty="0">
               <a:solidFill>
@@ -14466,122 +14270,6 @@
               <a:latin typeface="+mn-lt"/>
             </a:endParaRPr>
           </a:p>
-          <a:p>
-            <a:pPr marL="0" indent="0" algn="just">
-              <a:buNone/>
-            </a:pPr>
-            <a:endParaRPr lang="ru-RU" sz="3600" dirty="0">
-              <a:solidFill>
-                <a:schemeClr val="tx1"/>
-              </a:solidFill>
-              <a:latin typeface="+mn-lt"/>
-            </a:endParaRPr>
-          </a:p>
-          <a:p>
-            <a:pPr marL="0" indent="0" algn="just">
-              <a:buNone/>
-            </a:pPr>
-            <a:r>
-              <a:rPr lang="ru-RU" sz="3600" dirty="0" err="1">
-                <a:solidFill>
-                  <a:schemeClr val="tx1"/>
-                </a:solidFill>
-                <a:effectLst/>
-                <a:latin typeface="+mn-lt"/>
-              </a:rPr>
-              <a:t>Коммиты</a:t>
-            </a:r>
-            <a:r>
-              <a:rPr lang="ru-RU" sz="3600" dirty="0">
-                <a:solidFill>
-                  <a:schemeClr val="tx1"/>
-                </a:solidFill>
-                <a:effectLst/>
-                <a:latin typeface="+mn-lt"/>
-              </a:rPr>
-              <a:t> - это </a:t>
-            </a:r>
-            <a:r>
-              <a:rPr lang="ru-RU" sz="3600" dirty="0" err="1">
-                <a:solidFill>
-                  <a:schemeClr val="tx1"/>
-                </a:solidFill>
-                <a:effectLst/>
-                <a:latin typeface="+mn-lt"/>
-              </a:rPr>
-              <a:t>чекпойнты</a:t>
-            </a:r>
-            <a:r>
-              <a:rPr lang="ru-RU" sz="3600" dirty="0">
-                <a:solidFill>
-                  <a:schemeClr val="tx1"/>
-                </a:solidFill>
-                <a:effectLst/>
-                <a:latin typeface="+mn-lt"/>
-              </a:rPr>
-              <a:t> (как сохранения в игре), на которые мы можем </a:t>
-            </a:r>
-            <a:r>
-              <a:rPr lang="ru-RU" sz="3600" dirty="0" err="1">
-                <a:solidFill>
-                  <a:schemeClr val="tx1"/>
-                </a:solidFill>
-                <a:effectLst/>
-                <a:latin typeface="+mn-lt"/>
-              </a:rPr>
-              <a:t>перейти</a:t>
-            </a:r>
-            <a:r>
-              <a:rPr lang="ru-RU" sz="3600" dirty="0">
-                <a:solidFill>
-                  <a:schemeClr val="tx1"/>
-                </a:solidFill>
-                <a:effectLst/>
-                <a:latin typeface="+mn-lt"/>
-              </a:rPr>
-              <a:t>, получив состояние </a:t>
-            </a:r>
-            <a:r>
-              <a:rPr lang="ru-RU" sz="3600" dirty="0" err="1">
-                <a:solidFill>
-                  <a:schemeClr val="tx1"/>
-                </a:solidFill>
-                <a:effectLst/>
-                <a:latin typeface="+mn-lt"/>
-              </a:rPr>
-              <a:t>репозитория</a:t>
-            </a:r>
-            <a:r>
-              <a:rPr lang="ru-RU" sz="3600" dirty="0">
-                <a:solidFill>
-                  <a:schemeClr val="tx1"/>
-                </a:solidFill>
-                <a:effectLst/>
-                <a:latin typeface="+mn-lt"/>
-              </a:rPr>
-              <a:t>, которое было на момент </a:t>
-            </a:r>
-            <a:r>
-              <a:rPr lang="ru-RU" sz="3600" dirty="0" err="1">
-                <a:solidFill>
-                  <a:schemeClr val="tx1"/>
-                </a:solidFill>
-                <a:effectLst/>
-                <a:latin typeface="+mn-lt"/>
-              </a:rPr>
-              <a:t>коммита</a:t>
-            </a:r>
-            <a:r>
-              <a:rPr lang="ru-RU" sz="3600" dirty="0">
-                <a:solidFill>
-                  <a:schemeClr val="tx1"/>
-                </a:solidFill>
-                <a:effectLst/>
-                <a:latin typeface="+mn-lt"/>
-              </a:rPr>
-              <a:t> (сохранения)</a:t>
-            </a:r>
-          </a:p>
         </p:txBody>
       </p:sp>
       <p:sp>
@@ -14607,506 +14295,6 @@
               </a:rPr>
               <a:pPr/>
               <a:t>6</a:t>
-            </a:fld>
-            <a:endParaRPr lang="ru-RU" dirty="0">
-              <a:latin typeface="Tahoma" panose="020B0604030504040204" pitchFamily="34" charset="0"/>
-              <a:ea typeface="Tahoma" panose="020B0604030504040204" pitchFamily="34" charset="0"/>
-              <a:cs typeface="Tahoma" panose="020B0604030504040204" pitchFamily="34" charset="0"/>
-            </a:endParaRPr>
-          </a:p>
-        </p:txBody>
-      </p:sp>
-    </p:spTree>
-    <p:extLst>
-      <p:ext uri="{BB962C8B-B14F-4D97-AF65-F5344CB8AC3E}">
-        <p14:creationId xmlns:p14="http://schemas.microsoft.com/office/powerpoint/2010/main" val="2980489095"/>
-      </p:ext>
-    </p:extLst>
-  </p:cSld>
-  <p:clrMapOvr>
-    <a:masterClrMapping/>
-  </p:clrMapOvr>
-</p:sld>
-</file>
-
-<file path=ppt/slides/slide7.xml><?xml version="1.0" encoding="utf-8"?>
-<p:sld xmlns:a="http://schemas.openxmlformats.org/drawingml/2006/main" xmlns:r="http://schemas.openxmlformats.org/officeDocument/2006/relationships" xmlns:p="http://schemas.openxmlformats.org/presentationml/2006/main">
-  <p:cSld>
-    <p:spTree>
-      <p:nvGrpSpPr>
-        <p:cNvPr id="1" name=""/>
-        <p:cNvGrpSpPr/>
-        <p:nvPr/>
-      </p:nvGrpSpPr>
-      <p:grpSpPr>
-        <a:xfrm>
-          <a:off x="0" y="0"/>
-          <a:ext cx="0" cy="0"/>
-          <a:chOff x="0" y="0"/>
-          <a:chExt cx="0" cy="0"/>
-        </a:xfrm>
-      </p:grpSpPr>
-      <p:sp>
-        <p:nvSpPr>
-          <p:cNvPr id="12" name="Заголовок 11"/>
-          <p:cNvSpPr>
-            <a:spLocks noGrp="1"/>
-          </p:cNvSpPr>
-          <p:nvPr>
-            <p:ph type="ctrTitle"/>
-          </p:nvPr>
-        </p:nvSpPr>
-        <p:spPr>
-          <a:xfrm>
-            <a:off x="1298515" y="2115691"/>
-            <a:ext cx="14754286" cy="1103759"/>
-          </a:xfrm>
-        </p:spPr>
-        <p:txBody>
-          <a:bodyPr/>
-          <a:lstStyle/>
-          <a:p>
-            <a:r>
-              <a:rPr lang="en-US" sz="7200" b="1" dirty="0" err="1">
-                <a:latin typeface="Tahoma" panose="020B0604030504040204" pitchFamily="34" charset="0"/>
-                <a:ea typeface="Tahoma" panose="020B0604030504040204" pitchFamily="34" charset="0"/>
-                <a:cs typeface="Tahoma" panose="020B0604030504040204" pitchFamily="34" charset="0"/>
-              </a:rPr>
-              <a:t>Ко</a:t>
-            </a:r>
-            <a:r>
-              <a:rPr lang="ru-RU" sz="7200" b="1" dirty="0" err="1">
-                <a:latin typeface="Tahoma" panose="020B0604030504040204" pitchFamily="34" charset="0"/>
-                <a:ea typeface="Tahoma" panose="020B0604030504040204" pitchFamily="34" charset="0"/>
-                <a:cs typeface="Tahoma" panose="020B0604030504040204" pitchFamily="34" charset="0"/>
-              </a:rPr>
-              <a:t>нцепция</a:t>
-            </a:r>
-            <a:r>
-              <a:rPr lang="ru-RU" sz="7200" b="1" dirty="0">
-                <a:latin typeface="Tahoma" panose="020B0604030504040204" pitchFamily="34" charset="0"/>
-                <a:ea typeface="Tahoma" panose="020B0604030504040204" pitchFamily="34" charset="0"/>
-                <a:cs typeface="Tahoma" panose="020B0604030504040204" pitchFamily="34" charset="0"/>
-              </a:rPr>
-              <a:t> веток</a:t>
-            </a:r>
-          </a:p>
-        </p:txBody>
-      </p:sp>
-      <p:sp>
-        <p:nvSpPr>
-          <p:cNvPr id="14" name="Текст 13"/>
-          <p:cNvSpPr>
-            <a:spLocks noGrp="1"/>
-          </p:cNvSpPr>
-          <p:nvPr>
-            <p:ph type="body" sz="quarter" idx="12"/>
-          </p:nvPr>
-        </p:nvSpPr>
-        <p:spPr>
-          <a:xfrm>
-            <a:off x="3049608" y="4380584"/>
-            <a:ext cx="18283195" cy="6542999"/>
-          </a:xfrm>
-          <a:noFill/>
-        </p:spPr>
-        <p:txBody>
-          <a:bodyPr/>
-          <a:lstStyle/>
-          <a:p>
-            <a:pPr marL="0" indent="0" algn="just">
-              <a:buNone/>
-            </a:pPr>
-            <a:r>
-              <a:rPr lang="ru-RU" sz="3600" b="1" dirty="0">
-                <a:solidFill>
-                  <a:schemeClr val="tx1"/>
-                </a:solidFill>
-                <a:latin typeface="+mn-lt"/>
-              </a:rPr>
-              <a:t>Ветки</a:t>
-            </a:r>
-            <a:r>
-              <a:rPr lang="ru-RU" sz="3600" dirty="0">
-                <a:solidFill>
-                  <a:schemeClr val="tx1"/>
-                </a:solidFill>
-                <a:latin typeface="+mn-lt"/>
-              </a:rPr>
-              <a:t> - </a:t>
-            </a:r>
-            <a:r>
-              <a:rPr lang="ru-RU" sz="3600" dirty="0">
-                <a:solidFill>
-                  <a:schemeClr val="tx1"/>
-                </a:solidFill>
-                <a:effectLst/>
-                <a:latin typeface="+mn-lt"/>
-              </a:rPr>
-              <a:t>это инструмент для </a:t>
-            </a:r>
-            <a:r>
-              <a:rPr lang="ru-RU" sz="3600" dirty="0" err="1">
-                <a:solidFill>
-                  <a:schemeClr val="tx1"/>
-                </a:solidFill>
-                <a:effectLst/>
-                <a:latin typeface="+mn-lt"/>
-              </a:rPr>
-              <a:t>команднои</a:t>
-            </a:r>
-            <a:r>
-              <a:rPr lang="ru-RU" sz="3600" dirty="0">
-                <a:solidFill>
-                  <a:schemeClr val="tx1"/>
-                </a:solidFill>
-                <a:effectLst/>
-                <a:latin typeface="+mn-lt"/>
-              </a:rPr>
-              <a:t>̆ работы в гите. Создавая ветвь, мы получаем параллельную вселенную, где сначала всё так же, как в </a:t>
-            </a:r>
-            <a:r>
-              <a:rPr lang="ru-RU" sz="3600" dirty="0" err="1">
-                <a:solidFill>
-                  <a:schemeClr val="tx1"/>
-                </a:solidFill>
-                <a:effectLst/>
-                <a:latin typeface="+mn-lt"/>
-              </a:rPr>
-              <a:t>основнои</a:t>
-            </a:r>
-            <a:r>
-              <a:rPr lang="ru-RU" sz="3600" dirty="0">
-                <a:solidFill>
-                  <a:schemeClr val="tx1"/>
-                </a:solidFill>
-                <a:effectLst/>
-                <a:latin typeface="+mn-lt"/>
-              </a:rPr>
-              <a:t>̆ ветке </a:t>
-            </a:r>
-            <a:r>
-              <a:rPr lang="en" sz="3600" dirty="0">
-                <a:solidFill>
-                  <a:schemeClr val="tx1"/>
-                </a:solidFill>
-                <a:effectLst/>
-                <a:latin typeface="+mn-lt"/>
-              </a:rPr>
-              <a:t>master. </a:t>
-            </a:r>
-            <a:r>
-              <a:rPr lang="ru-RU" sz="3600" dirty="0">
-                <a:solidFill>
-                  <a:schemeClr val="tx1"/>
-                </a:solidFill>
-                <a:effectLst/>
-                <a:latin typeface="+mn-lt"/>
-              </a:rPr>
-              <a:t>Меняя код в </a:t>
-            </a:r>
-            <a:r>
-              <a:rPr lang="ru-RU" sz="3600" dirty="0" err="1">
-                <a:solidFill>
-                  <a:schemeClr val="tx1"/>
-                </a:solidFill>
-                <a:effectLst/>
-                <a:latin typeface="+mn-lt"/>
-              </a:rPr>
-              <a:t>однои</a:t>
-            </a:r>
-            <a:r>
-              <a:rPr lang="ru-RU" sz="3600" dirty="0">
-                <a:solidFill>
-                  <a:schemeClr val="tx1"/>
-                </a:solidFill>
-                <a:effectLst/>
-                <a:latin typeface="+mn-lt"/>
-              </a:rPr>
-              <a:t>̆ ветке, состояние </a:t>
-            </a:r>
-            <a:r>
-              <a:rPr lang="ru-RU" sz="3600" dirty="0" err="1">
-                <a:solidFill>
-                  <a:schemeClr val="tx1"/>
-                </a:solidFill>
-                <a:effectLst/>
-                <a:latin typeface="+mn-lt"/>
-              </a:rPr>
-              <a:t>другои</a:t>
-            </a:r>
-            <a:r>
-              <a:rPr lang="ru-RU" sz="3600" dirty="0">
-                <a:solidFill>
-                  <a:schemeClr val="tx1"/>
-                </a:solidFill>
-                <a:effectLst/>
-                <a:latin typeface="+mn-lt"/>
-              </a:rPr>
-              <a:t>̆ </a:t>
-            </a:r>
-            <a:r>
-              <a:rPr lang="ru-RU" sz="3600" dirty="0" err="1">
-                <a:solidFill>
-                  <a:schemeClr val="tx1"/>
-                </a:solidFill>
-                <a:effectLst/>
-                <a:latin typeface="+mn-lt"/>
-              </a:rPr>
-              <a:t>остаётся</a:t>
-            </a:r>
-            <a:r>
-              <a:rPr lang="ru-RU" sz="3600" dirty="0">
-                <a:solidFill>
-                  <a:schemeClr val="tx1"/>
-                </a:solidFill>
-                <a:effectLst/>
-                <a:latin typeface="+mn-lt"/>
-              </a:rPr>
-              <a:t> прежним, то есть ветки могут развиваться независимо друг от друга </a:t>
-            </a:r>
-          </a:p>
-          <a:p>
-            <a:pPr marL="0" indent="0" algn="just">
-              <a:buNone/>
-            </a:pPr>
-            <a:endParaRPr lang="ru-RU" sz="2000" dirty="0">
-              <a:effectLst/>
-            </a:endParaRPr>
-          </a:p>
-          <a:p>
-            <a:pPr marL="0" indent="0" algn="just">
-              <a:buNone/>
-            </a:pPr>
-            <a:r>
-              <a:rPr lang="ru-RU" sz="3600" dirty="0">
-                <a:solidFill>
-                  <a:schemeClr val="tx1"/>
-                </a:solidFill>
-                <a:latin typeface="+mn-lt"/>
-              </a:rPr>
-              <a:t> </a:t>
-            </a:r>
-            <a:r>
-              <a:rPr lang="ru-RU" sz="3600" b="1" dirty="0" err="1">
-                <a:solidFill>
-                  <a:schemeClr val="tx1"/>
-                </a:solidFill>
-                <a:latin typeface="+mn-lt"/>
-              </a:rPr>
-              <a:t>g</a:t>
-            </a:r>
-            <a:r>
-              <a:rPr lang="en-US" sz="3600" b="1" dirty="0">
-                <a:solidFill>
-                  <a:schemeClr val="tx1"/>
-                </a:solidFill>
-                <a:latin typeface="+mn-lt"/>
-              </a:rPr>
-              <a:t>it branch </a:t>
-            </a:r>
-            <a:r>
-              <a:rPr lang="en-US" sz="3600" dirty="0">
-                <a:solidFill>
-                  <a:schemeClr val="tx1"/>
-                </a:solidFill>
-                <a:latin typeface="+mn-lt"/>
-              </a:rPr>
-              <a:t>-&gt; </a:t>
-            </a:r>
-            <a:r>
-              <a:rPr lang="ru-RU" sz="3600" dirty="0">
-                <a:solidFill>
-                  <a:schemeClr val="tx1"/>
-                </a:solidFill>
-                <a:latin typeface="+mn-lt"/>
-              </a:rPr>
-              <a:t>покажет список всех веток и рядом с </a:t>
-            </a:r>
-            <a:r>
-              <a:rPr lang="en-US" sz="3600" dirty="0">
-                <a:solidFill>
-                  <a:schemeClr val="tx1"/>
-                </a:solidFill>
-                <a:latin typeface="+mn-lt"/>
-              </a:rPr>
-              <a:t>“</a:t>
-            </a:r>
-            <a:r>
-              <a:rPr lang="ru-RU" sz="3600" dirty="0">
-                <a:solidFill>
-                  <a:schemeClr val="tx1"/>
-                </a:solidFill>
-                <a:latin typeface="+mn-lt"/>
-              </a:rPr>
-              <a:t>*</a:t>
-            </a:r>
-            <a:r>
-              <a:rPr lang="en-US" sz="3600" dirty="0">
-                <a:solidFill>
-                  <a:schemeClr val="tx1"/>
-                </a:solidFill>
-                <a:latin typeface="+mn-lt"/>
-              </a:rPr>
-              <a:t>”</a:t>
-            </a:r>
-            <a:r>
-              <a:rPr lang="ru-RU" sz="3600" dirty="0">
-                <a:solidFill>
-                  <a:schemeClr val="tx1"/>
-                </a:solidFill>
-                <a:latin typeface="+mn-lt"/>
-              </a:rPr>
-              <a:t> ту, в которой вы находитесь</a:t>
-            </a:r>
-          </a:p>
-          <a:p>
-            <a:pPr marL="0" indent="0" algn="just">
-              <a:buNone/>
-            </a:pPr>
-            <a:endParaRPr lang="ru-RU" sz="3600" dirty="0">
-              <a:solidFill>
-                <a:schemeClr val="tx1"/>
-              </a:solidFill>
-              <a:latin typeface="+mn-lt"/>
-            </a:endParaRPr>
-          </a:p>
-          <a:p>
-            <a:pPr marL="0" indent="0" algn="just">
-              <a:buNone/>
-            </a:pPr>
-            <a:r>
-              <a:rPr lang="en" sz="3600" dirty="0">
-                <a:solidFill>
-                  <a:schemeClr val="tx1"/>
-                </a:solidFill>
-                <a:latin typeface="+mn-lt"/>
-              </a:rPr>
-              <a:t> </a:t>
-            </a:r>
-            <a:r>
-              <a:rPr lang="en" sz="3600" b="1" dirty="0">
-                <a:solidFill>
-                  <a:schemeClr val="tx1"/>
-                </a:solidFill>
-                <a:latin typeface="+mn-lt"/>
-              </a:rPr>
-              <a:t>git branch &lt;name&gt; </a:t>
-            </a:r>
-            <a:r>
-              <a:rPr lang="ru-RU" sz="3600" dirty="0">
-                <a:solidFill>
-                  <a:schemeClr val="tx1"/>
-                </a:solidFill>
-                <a:latin typeface="+mn-lt"/>
-              </a:rPr>
-              <a:t>создаст новую ветку с именем </a:t>
-            </a:r>
-            <a:r>
-              <a:rPr lang="en-US" sz="3600" dirty="0">
-                <a:solidFill>
-                  <a:schemeClr val="tx1"/>
-                </a:solidFill>
-                <a:latin typeface="+mn-lt"/>
-              </a:rPr>
-              <a:t>name</a:t>
-            </a:r>
-          </a:p>
-          <a:p>
-            <a:pPr marL="0" indent="0" algn="just">
-              <a:buNone/>
-            </a:pPr>
-            <a:r>
-              <a:rPr lang="en-US" sz="3600" dirty="0">
-                <a:solidFill>
-                  <a:schemeClr val="tx1"/>
-                </a:solidFill>
-                <a:latin typeface="+mn-lt"/>
-              </a:rPr>
-              <a:t> </a:t>
-            </a:r>
-          </a:p>
-          <a:p>
-            <a:pPr marL="0" indent="0" algn="just">
-              <a:buNone/>
-            </a:pPr>
-            <a:r>
-              <a:rPr lang="en-US" sz="3600" dirty="0">
-                <a:solidFill>
-                  <a:schemeClr val="tx1"/>
-                </a:solidFill>
-                <a:latin typeface="+mn-lt"/>
-              </a:rPr>
-              <a:t> </a:t>
-            </a:r>
-            <a:r>
-              <a:rPr lang="en-US" sz="3600" b="1" dirty="0">
-                <a:solidFill>
-                  <a:schemeClr val="tx1"/>
-                </a:solidFill>
-                <a:latin typeface="+mn-lt"/>
-              </a:rPr>
-              <a:t>git checkout &lt;name&gt; </a:t>
-            </a:r>
-            <a:r>
-              <a:rPr lang="ru-RU" sz="3600" dirty="0">
-                <a:solidFill>
-                  <a:schemeClr val="tx1"/>
-                </a:solidFill>
-                <a:latin typeface="+mn-lt"/>
-              </a:rPr>
-              <a:t>переключится на ветку с именем </a:t>
-            </a:r>
-            <a:r>
-              <a:rPr lang="ru-RU" sz="3600" dirty="0" err="1">
-                <a:solidFill>
-                  <a:schemeClr val="tx1"/>
-                </a:solidFill>
-                <a:latin typeface="+mn-lt"/>
-              </a:rPr>
-              <a:t>n</a:t>
-            </a:r>
-            <a:r>
-              <a:rPr lang="en-US" sz="3600" dirty="0" err="1">
-                <a:solidFill>
-                  <a:schemeClr val="tx1"/>
-                </a:solidFill>
-                <a:latin typeface="+mn-lt"/>
-              </a:rPr>
-              <a:t>ame</a:t>
-            </a:r>
-            <a:endParaRPr lang="ru-RU" sz="3600" dirty="0">
-              <a:solidFill>
-                <a:schemeClr val="tx1"/>
-              </a:solidFill>
-              <a:latin typeface="+mn-lt"/>
-            </a:endParaRPr>
-          </a:p>
-        </p:txBody>
-      </p:sp>
-      <p:sp>
-        <p:nvSpPr>
-          <p:cNvPr id="18" name="Номер слайда 17"/>
-          <p:cNvSpPr>
-            <a:spLocks noGrp="1"/>
-          </p:cNvSpPr>
-          <p:nvPr>
-            <p:ph type="sldNum" sz="quarter" idx="20"/>
-          </p:nvPr>
-        </p:nvSpPr>
-        <p:spPr/>
-        <p:txBody>
-          <a:bodyPr/>
-          <a:lstStyle/>
-          <a:p>
-            <a:fld id="{66B5E2A4-72D4-4DC4-9470-54C0EE06E412}" type="slidenum">
-              <a:rPr lang="ru-RU" smtClean="0">
-                <a:latin typeface="Tahoma" panose="020B0604030504040204" pitchFamily="34" charset="0"/>
-                <a:ea typeface="Tahoma" panose="020B0604030504040204" pitchFamily="34" charset="0"/>
-                <a:cs typeface="Tahoma" panose="020B0604030504040204" pitchFamily="34" charset="0"/>
-              </a:rPr>
-              <a:pPr/>
-              <a:t>7</a:t>
             </a:fld>
             <a:endParaRPr lang="ru-RU" dirty="0">
               <a:latin typeface="Tahoma" panose="020B0604030504040204" pitchFamily="34" charset="0"/>
@@ -15176,18 +14364,12 @@
 </p:sld>
 </file>
 
-<file path=ppt/slides/slide8.xml><?xml version="1.0" encoding="utf-8"?>
+<file path=ppt/slides/slide7.xml><?xml version="1.0" encoding="utf-8"?>
 <p:sld xmlns:a="http://schemas.openxmlformats.org/drawingml/2006/main" xmlns:r="http://schemas.openxmlformats.org/officeDocument/2006/relationships" xmlns:p="http://schemas.openxmlformats.org/presentationml/2006/main">
   <p:cSld>
     <p:spTree>
       <p:nvGrpSpPr>
-        <p:cNvPr id="1" name="">
-          <a:extLst>
-            <a:ext uri="{FF2B5EF4-FFF2-40B4-BE49-F238E27FC236}">
-              <a16:creationId xmlns:a16="http://schemas.microsoft.com/office/drawing/2014/main" id="{7EAEA7AB-8D63-2734-314F-F762D84F708A}"/>
-            </a:ext>
-          </a:extLst>
-        </p:cNvPr>
+        <p:cNvPr id="1" name=""/>
         <p:cNvGrpSpPr/>
         <p:nvPr/>
       </p:nvGrpSpPr>
@@ -15201,13 +14383,7 @@
       </p:grpSpPr>
       <p:sp>
         <p:nvSpPr>
-          <p:cNvPr id="12" name="Заголовок 11">
-            <a:extLst>
-              <a:ext uri="{FF2B5EF4-FFF2-40B4-BE49-F238E27FC236}">
-                <a16:creationId xmlns:a16="http://schemas.microsoft.com/office/drawing/2014/main" id="{BE58A4F9-57AD-5E2E-35FE-3BA5D85E21D8}"/>
-              </a:ext>
-            </a:extLst>
-          </p:cNvPr>
+          <p:cNvPr id="12" name="Заголовок 11"/>
           <p:cNvSpPr>
             <a:spLocks noGrp="1"/>
           </p:cNvSpPr>
@@ -15231,20 +14407,1006 @@
                 <a:ea typeface="Tahoma" panose="020B0604030504040204" pitchFamily="34" charset="0"/>
                 <a:cs typeface="Tahoma" panose="020B0604030504040204" pitchFamily="34" charset="0"/>
               </a:rPr>
-              <a:t>Пауза на вопросы</a:t>
-            </a:r>
-          </a:p>
-        </p:txBody>
-      </p:sp>
-      <p:sp>
-        <p:nvSpPr>
-          <p:cNvPr id="18" name="Номер слайда 17">
-            <a:extLst>
-              <a:ext uri="{FF2B5EF4-FFF2-40B4-BE49-F238E27FC236}">
-                <a16:creationId xmlns:a16="http://schemas.microsoft.com/office/drawing/2014/main" id="{B9912B64-B497-84CC-E350-BF3E7B2EB803}"/>
-              </a:ext>
-            </a:extLst>
-          </p:cNvPr>
+              <a:t>Статус </a:t>
+            </a:r>
+            <a:r>
+              <a:rPr lang="ru-RU" sz="7200" b="1" dirty="0" err="1">
+                <a:latin typeface="Tahoma" panose="020B0604030504040204" pitchFamily="34" charset="0"/>
+                <a:ea typeface="Tahoma" panose="020B0604030504040204" pitchFamily="34" charset="0"/>
+                <a:cs typeface="Tahoma" panose="020B0604030504040204" pitchFamily="34" charset="0"/>
+              </a:rPr>
+              <a:t>репозитория</a:t>
+            </a:r>
+            <a:endParaRPr lang="ru-RU" sz="7200" b="1" dirty="0">
+              <a:latin typeface="Tahoma" panose="020B0604030504040204" pitchFamily="34" charset="0"/>
+              <a:ea typeface="Tahoma" panose="020B0604030504040204" pitchFamily="34" charset="0"/>
+              <a:cs typeface="Tahoma" panose="020B0604030504040204" pitchFamily="34" charset="0"/>
+            </a:endParaRPr>
+          </a:p>
+        </p:txBody>
+      </p:sp>
+      <p:sp>
+        <p:nvSpPr>
+          <p:cNvPr id="14" name="Текст 13"/>
+          <p:cNvSpPr>
+            <a:spLocks noGrp="1"/>
+          </p:cNvSpPr>
+          <p:nvPr>
+            <p:ph type="body" sz="quarter" idx="12"/>
+          </p:nvPr>
+        </p:nvSpPr>
+        <p:spPr>
+          <a:xfrm>
+            <a:off x="3049608" y="4380584"/>
+            <a:ext cx="18283195" cy="6542999"/>
+          </a:xfrm>
+          <a:noFill/>
+        </p:spPr>
+        <p:txBody>
+          <a:bodyPr/>
+          <a:lstStyle/>
+          <a:p>
+            <a:pPr marL="0" indent="0" algn="just">
+              <a:buNone/>
+            </a:pPr>
+            <a:r>
+              <a:rPr lang="en-US" sz="3600" b="1" dirty="0">
+                <a:solidFill>
+                  <a:schemeClr val="tx1"/>
+                </a:solidFill>
+                <a:latin typeface="+mn-lt"/>
+              </a:rPr>
+              <a:t>git status </a:t>
+            </a:r>
+            <a:r>
+              <a:rPr lang="en-US" sz="3600" dirty="0">
+                <a:solidFill>
+                  <a:schemeClr val="tx1"/>
+                </a:solidFill>
+                <a:latin typeface="+mn-lt"/>
+              </a:rPr>
+              <a:t>– </a:t>
+            </a:r>
+            <a:r>
+              <a:rPr lang="ru-RU" sz="3600" dirty="0">
+                <a:solidFill>
+                  <a:schemeClr val="tx1"/>
+                </a:solidFill>
+                <a:latin typeface="+mn-lt"/>
+              </a:rPr>
+              <a:t>позволяет узнать текущее состоянии </a:t>
+            </a:r>
+            <a:r>
+              <a:rPr lang="ru-RU" sz="3600" dirty="0" err="1">
+                <a:solidFill>
+                  <a:schemeClr val="tx1"/>
+                </a:solidFill>
+                <a:latin typeface="+mn-lt"/>
+              </a:rPr>
+              <a:t>репозитория</a:t>
+            </a:r>
+            <a:endParaRPr lang="en-US" sz="3600" dirty="0">
+              <a:solidFill>
+                <a:schemeClr val="tx1"/>
+              </a:solidFill>
+              <a:latin typeface="+mn-lt"/>
+            </a:endParaRPr>
+          </a:p>
+          <a:p>
+            <a:pPr marL="0" indent="0" algn="just">
+              <a:buNone/>
+            </a:pPr>
+            <a:endParaRPr lang="ru-RU" sz="3600" dirty="0">
+              <a:solidFill>
+                <a:schemeClr val="tx1"/>
+              </a:solidFill>
+              <a:latin typeface="+mn-lt"/>
+            </a:endParaRPr>
+          </a:p>
+          <a:p>
+            <a:pPr marL="0" indent="0" algn="just">
+              <a:buNone/>
+            </a:pPr>
+            <a:endParaRPr lang="en-US" sz="3600" dirty="0">
+              <a:solidFill>
+                <a:schemeClr val="tx1"/>
+              </a:solidFill>
+              <a:latin typeface="+mn-lt"/>
+            </a:endParaRPr>
+          </a:p>
+          <a:p>
+            <a:pPr marL="0" indent="0" algn="just">
+              <a:buNone/>
+            </a:pPr>
+            <a:r>
+              <a:rPr lang="en" sz="3600" b="1" dirty="0">
+                <a:solidFill>
+                  <a:schemeClr val="tx1"/>
+                </a:solidFill>
+                <a:latin typeface="+mn-lt"/>
+              </a:rPr>
+              <a:t>g</a:t>
+            </a:r>
+            <a:r>
+              <a:rPr lang="en-US" sz="3600" b="1" dirty="0">
+                <a:solidFill>
+                  <a:schemeClr val="tx1"/>
+                </a:solidFill>
+                <a:latin typeface="+mn-lt"/>
+              </a:rPr>
+              <a:t>it log</a:t>
+            </a:r>
+            <a:r>
+              <a:rPr lang="ru-RU" sz="3600" b="1" dirty="0">
+                <a:solidFill>
+                  <a:schemeClr val="tx1"/>
+                </a:solidFill>
+                <a:latin typeface="+mn-lt"/>
+              </a:rPr>
+              <a:t> </a:t>
+            </a:r>
+            <a:r>
+              <a:rPr lang="ru-RU" sz="3600" dirty="0">
+                <a:solidFill>
+                  <a:schemeClr val="tx1"/>
+                </a:solidFill>
+                <a:latin typeface="+mn-lt"/>
+              </a:rPr>
+              <a:t>- покажет всю историю </a:t>
+            </a:r>
+            <a:r>
+              <a:rPr lang="ru-RU" sz="3600" dirty="0" err="1">
+                <a:solidFill>
+                  <a:schemeClr val="tx1"/>
+                </a:solidFill>
+                <a:latin typeface="+mn-lt"/>
+              </a:rPr>
+              <a:t>коммитов</a:t>
+            </a:r>
+            <a:endParaRPr lang="ru-RU" sz="3600" dirty="0">
+              <a:solidFill>
+                <a:schemeClr val="tx1"/>
+              </a:solidFill>
+              <a:latin typeface="+mn-lt"/>
+            </a:endParaRPr>
+          </a:p>
+          <a:p>
+            <a:pPr marL="0" indent="0" algn="just">
+              <a:buNone/>
+            </a:pPr>
+            <a:endParaRPr lang="ru-RU" sz="3600" dirty="0">
+              <a:solidFill>
+                <a:schemeClr val="tx1"/>
+              </a:solidFill>
+              <a:latin typeface="+mn-lt"/>
+            </a:endParaRPr>
+          </a:p>
+          <a:p>
+            <a:pPr marL="0" indent="0" algn="just">
+              <a:buNone/>
+            </a:pPr>
+            <a:r>
+              <a:rPr lang="ru-RU" sz="3600" dirty="0" err="1">
+                <a:solidFill>
+                  <a:schemeClr val="tx1"/>
+                </a:solidFill>
+                <a:effectLst/>
+                <a:latin typeface="+mn-lt"/>
+              </a:rPr>
+              <a:t>Коммиты</a:t>
+            </a:r>
+            <a:r>
+              <a:rPr lang="ru-RU" sz="3600" dirty="0">
+                <a:solidFill>
+                  <a:schemeClr val="tx1"/>
+                </a:solidFill>
+                <a:effectLst/>
+                <a:latin typeface="+mn-lt"/>
+              </a:rPr>
+              <a:t> - это </a:t>
+            </a:r>
+            <a:r>
+              <a:rPr lang="ru-RU" sz="3600" dirty="0" err="1">
+                <a:solidFill>
+                  <a:schemeClr val="tx1"/>
+                </a:solidFill>
+                <a:effectLst/>
+                <a:latin typeface="+mn-lt"/>
+              </a:rPr>
+              <a:t>чекпойнты</a:t>
+            </a:r>
+            <a:r>
+              <a:rPr lang="ru-RU" sz="3600" dirty="0">
+                <a:solidFill>
+                  <a:schemeClr val="tx1"/>
+                </a:solidFill>
+                <a:effectLst/>
+                <a:latin typeface="+mn-lt"/>
+              </a:rPr>
+              <a:t> (как сохранения в игре), на которые мы можем </a:t>
+            </a:r>
+            <a:r>
+              <a:rPr lang="ru-RU" sz="3600" dirty="0" err="1">
+                <a:solidFill>
+                  <a:schemeClr val="tx1"/>
+                </a:solidFill>
+                <a:effectLst/>
+                <a:latin typeface="+mn-lt"/>
+              </a:rPr>
+              <a:t>перейти</a:t>
+            </a:r>
+            <a:r>
+              <a:rPr lang="ru-RU" sz="3600" dirty="0">
+                <a:solidFill>
+                  <a:schemeClr val="tx1"/>
+                </a:solidFill>
+                <a:effectLst/>
+                <a:latin typeface="+mn-lt"/>
+              </a:rPr>
+              <a:t>, получив состояние </a:t>
+            </a:r>
+            <a:r>
+              <a:rPr lang="ru-RU" sz="3600" dirty="0" err="1">
+                <a:solidFill>
+                  <a:schemeClr val="tx1"/>
+                </a:solidFill>
+                <a:effectLst/>
+                <a:latin typeface="+mn-lt"/>
+              </a:rPr>
+              <a:t>репозитория</a:t>
+            </a:r>
+            <a:r>
+              <a:rPr lang="ru-RU" sz="3600" dirty="0">
+                <a:solidFill>
+                  <a:schemeClr val="tx1"/>
+                </a:solidFill>
+                <a:effectLst/>
+                <a:latin typeface="+mn-lt"/>
+              </a:rPr>
+              <a:t>, которое было на момент </a:t>
+            </a:r>
+            <a:r>
+              <a:rPr lang="ru-RU" sz="3600" dirty="0" err="1">
+                <a:solidFill>
+                  <a:schemeClr val="tx1"/>
+                </a:solidFill>
+                <a:effectLst/>
+                <a:latin typeface="+mn-lt"/>
+              </a:rPr>
+              <a:t>коммита</a:t>
+            </a:r>
+            <a:r>
+              <a:rPr lang="ru-RU" sz="3600" dirty="0">
+                <a:solidFill>
+                  <a:schemeClr val="tx1"/>
+                </a:solidFill>
+                <a:effectLst/>
+                <a:latin typeface="+mn-lt"/>
+              </a:rPr>
+              <a:t> (сохранения)</a:t>
+            </a:r>
+          </a:p>
+        </p:txBody>
+      </p:sp>
+      <p:sp>
+        <p:nvSpPr>
+          <p:cNvPr id="18" name="Номер слайда 17"/>
+          <p:cNvSpPr>
+            <a:spLocks noGrp="1"/>
+          </p:cNvSpPr>
+          <p:nvPr>
+            <p:ph type="sldNum" sz="quarter" idx="20"/>
+          </p:nvPr>
+        </p:nvSpPr>
+        <p:spPr/>
+        <p:txBody>
+          <a:bodyPr/>
+          <a:lstStyle/>
+          <a:p>
+            <a:fld id="{66B5E2A4-72D4-4DC4-9470-54C0EE06E412}" type="slidenum">
+              <a:rPr lang="ru-RU" smtClean="0">
+                <a:latin typeface="Tahoma" panose="020B0604030504040204" pitchFamily="34" charset="0"/>
+                <a:ea typeface="Tahoma" panose="020B0604030504040204" pitchFamily="34" charset="0"/>
+                <a:cs typeface="Tahoma" panose="020B0604030504040204" pitchFamily="34" charset="0"/>
+              </a:rPr>
+              <a:pPr/>
+              <a:t>7</a:t>
+            </a:fld>
+            <a:endParaRPr lang="ru-RU" dirty="0">
+              <a:latin typeface="Tahoma" panose="020B0604030504040204" pitchFamily="34" charset="0"/>
+              <a:ea typeface="Tahoma" panose="020B0604030504040204" pitchFamily="34" charset="0"/>
+              <a:cs typeface="Tahoma" panose="020B0604030504040204" pitchFamily="34" charset="0"/>
+            </a:endParaRPr>
+          </a:p>
+        </p:txBody>
+      </p:sp>
+    </p:spTree>
+    <p:extLst>
+      <p:ext uri="{BB962C8B-B14F-4D97-AF65-F5344CB8AC3E}">
+        <p14:creationId xmlns:p14="http://schemas.microsoft.com/office/powerpoint/2010/main" val="2980489095"/>
+      </p:ext>
+    </p:extLst>
+  </p:cSld>
+  <p:clrMapOvr>
+    <a:masterClrMapping/>
+  </p:clrMapOvr>
+</p:sld>
+</file>
+
+<file path=ppt/slides/slide8.xml><?xml version="1.0" encoding="utf-8"?>
+<p:sld xmlns:a="http://schemas.openxmlformats.org/drawingml/2006/main" xmlns:r="http://schemas.openxmlformats.org/officeDocument/2006/relationships" xmlns:p="http://schemas.openxmlformats.org/presentationml/2006/main">
+  <p:cSld>
+    <p:spTree>
+      <p:nvGrpSpPr>
+        <p:cNvPr id="1" name=""/>
+        <p:cNvGrpSpPr/>
+        <p:nvPr/>
+      </p:nvGrpSpPr>
+      <p:grpSpPr>
+        <a:xfrm>
+          <a:off x="0" y="0"/>
+          <a:ext cx="0" cy="0"/>
+          <a:chOff x="0" y="0"/>
+          <a:chExt cx="0" cy="0"/>
+        </a:xfrm>
+      </p:grpSpPr>
+      <p:sp>
+        <p:nvSpPr>
+          <p:cNvPr id="12" name="Заголовок 11"/>
+          <p:cNvSpPr>
+            <a:spLocks noGrp="1"/>
+          </p:cNvSpPr>
+          <p:nvPr>
+            <p:ph type="ctrTitle"/>
+          </p:nvPr>
+        </p:nvSpPr>
+        <p:spPr>
+          <a:xfrm>
+            <a:off x="1298515" y="2115691"/>
+            <a:ext cx="11888095" cy="1103759"/>
+          </a:xfrm>
+        </p:spPr>
+        <p:txBody>
+          <a:bodyPr/>
+          <a:lstStyle/>
+          <a:p>
+            <a:r>
+              <a:rPr lang="en-US" sz="7200" b="1" dirty="0" err="1">
+                <a:latin typeface="Tahoma" panose="020B0604030504040204" pitchFamily="34" charset="0"/>
+                <a:ea typeface="Tahoma" panose="020B0604030504040204" pitchFamily="34" charset="0"/>
+                <a:cs typeface="Tahoma" panose="020B0604030504040204" pitchFamily="34" charset="0"/>
+              </a:rPr>
+              <a:t>К</a:t>
+            </a:r>
+            <a:r>
+              <a:rPr lang="ru-RU" sz="7200" b="1" dirty="0" err="1">
+                <a:latin typeface="Tahoma" panose="020B0604030504040204" pitchFamily="34" charset="0"/>
+                <a:ea typeface="Tahoma" panose="020B0604030504040204" pitchFamily="34" charset="0"/>
+                <a:cs typeface="Tahoma" panose="020B0604030504040204" pitchFamily="34" charset="0"/>
+              </a:rPr>
+              <a:t>оманды</a:t>
+            </a:r>
+            <a:r>
+              <a:rPr lang="ru-RU" sz="7200" b="1" dirty="0">
+                <a:latin typeface="Tahoma" panose="020B0604030504040204" pitchFamily="34" charset="0"/>
+                <a:ea typeface="Tahoma" panose="020B0604030504040204" pitchFamily="34" charset="0"/>
+                <a:cs typeface="Tahoma" panose="020B0604030504040204" pitchFamily="34" charset="0"/>
+              </a:rPr>
+              <a:t> </a:t>
+            </a:r>
+            <a:r>
+              <a:rPr lang="en-US" sz="7200" b="1" dirty="0">
+                <a:latin typeface="Tahoma" panose="020B0604030504040204" pitchFamily="34" charset="0"/>
+                <a:ea typeface="Tahoma" panose="020B0604030504040204" pitchFamily="34" charset="0"/>
+                <a:cs typeface="Tahoma" panose="020B0604030504040204" pitchFamily="34" charset="0"/>
+              </a:rPr>
+              <a:t>git</a:t>
+            </a:r>
+            <a:endParaRPr lang="ru-RU" sz="7200" b="1" dirty="0">
+              <a:latin typeface="Tahoma" panose="020B0604030504040204" pitchFamily="34" charset="0"/>
+              <a:ea typeface="Tahoma" panose="020B0604030504040204" pitchFamily="34" charset="0"/>
+              <a:cs typeface="Tahoma" panose="020B0604030504040204" pitchFamily="34" charset="0"/>
+            </a:endParaRPr>
+          </a:p>
+        </p:txBody>
+      </p:sp>
+      <p:sp>
+        <p:nvSpPr>
+          <p:cNvPr id="14" name="Текст 13"/>
+          <p:cNvSpPr>
+            <a:spLocks noGrp="1"/>
+          </p:cNvSpPr>
+          <p:nvPr>
+            <p:ph type="body" sz="quarter" idx="12"/>
+          </p:nvPr>
+        </p:nvSpPr>
+        <p:spPr>
+          <a:xfrm>
+            <a:off x="2840663" y="3488970"/>
+            <a:ext cx="18701085" cy="8111339"/>
+          </a:xfrm>
+        </p:spPr>
+        <p:txBody>
+          <a:bodyPr/>
+          <a:lstStyle/>
+          <a:p>
+            <a:pPr marL="0" indent="0">
+              <a:buNone/>
+            </a:pPr>
+            <a:r>
+              <a:rPr lang="en" sz="3600" b="1" dirty="0">
+                <a:solidFill>
+                  <a:schemeClr val="tx1"/>
+                </a:solidFill>
+                <a:effectLst/>
+                <a:latin typeface="+mn-lt"/>
+                <a:cs typeface="Times New Roman" panose="02020603050405020304" pitchFamily="18" charset="0"/>
+              </a:rPr>
+              <a:t>git clone link</a:t>
+            </a:r>
+            <a:endParaRPr lang="ru-RU" sz="3600" b="1" dirty="0">
+              <a:solidFill>
+                <a:schemeClr val="tx1"/>
+              </a:solidFill>
+              <a:effectLst/>
+              <a:latin typeface="+mn-lt"/>
+              <a:cs typeface="Times New Roman" panose="02020603050405020304" pitchFamily="18" charset="0"/>
+            </a:endParaRPr>
+          </a:p>
+          <a:p>
+            <a:pPr marL="0" indent="0">
+              <a:buNone/>
+            </a:pPr>
+            <a:r>
+              <a:rPr lang="ru-RU" sz="3600" dirty="0">
+                <a:solidFill>
+                  <a:schemeClr val="tx1"/>
+                </a:solidFill>
+                <a:effectLst/>
+                <a:latin typeface="+mn-lt"/>
+                <a:cs typeface="Times New Roman" panose="02020603050405020304" pitchFamily="18" charset="0"/>
+              </a:rPr>
+              <a:t>Клонирует </a:t>
+            </a:r>
+            <a:r>
+              <a:rPr lang="ru-RU" sz="3600" dirty="0" err="1">
+                <a:solidFill>
+                  <a:schemeClr val="tx1"/>
+                </a:solidFill>
+                <a:effectLst/>
+                <a:latin typeface="+mn-lt"/>
+                <a:cs typeface="Times New Roman" panose="02020603050405020304" pitchFamily="18" charset="0"/>
+              </a:rPr>
+              <a:t>репозитории</a:t>
+            </a:r>
+            <a:r>
+              <a:rPr lang="ru-RU" sz="3600" dirty="0">
+                <a:solidFill>
+                  <a:schemeClr val="tx1"/>
+                </a:solidFill>
+                <a:effectLst/>
+                <a:latin typeface="+mn-lt"/>
+                <a:cs typeface="Times New Roman" panose="02020603050405020304" pitchFamily="18" charset="0"/>
+              </a:rPr>
+              <a:t>̆ </a:t>
+            </a:r>
+            <a:r>
+              <a:rPr lang="ru-RU" sz="3600" dirty="0" err="1">
+                <a:solidFill>
+                  <a:schemeClr val="tx1"/>
+                </a:solidFill>
+                <a:effectLst/>
+                <a:latin typeface="+mn-lt"/>
+                <a:cs typeface="Times New Roman" panose="02020603050405020304" pitchFamily="18" charset="0"/>
+              </a:rPr>
+              <a:t>ссервера</a:t>
+            </a:r>
+            <a:r>
+              <a:rPr lang="ru-RU" sz="3600" dirty="0">
+                <a:solidFill>
+                  <a:schemeClr val="tx1"/>
+                </a:solidFill>
+                <a:effectLst/>
+                <a:latin typeface="+mn-lt"/>
+                <a:cs typeface="Times New Roman" panose="02020603050405020304" pitchFamily="18" charset="0"/>
+              </a:rPr>
+              <a:t> (</a:t>
+            </a:r>
+            <a:r>
+              <a:rPr lang="ru-RU" sz="3600" dirty="0" err="1">
+                <a:solidFill>
+                  <a:schemeClr val="tx1"/>
+                </a:solidFill>
+                <a:effectLst/>
+                <a:latin typeface="+mn-lt"/>
+                <a:cs typeface="Times New Roman" panose="02020603050405020304" pitchFamily="18" charset="0"/>
+              </a:rPr>
+              <a:t>сайта</a:t>
+            </a:r>
+            <a:r>
+              <a:rPr lang="ru-RU" sz="3600" dirty="0">
+                <a:solidFill>
+                  <a:schemeClr val="tx1"/>
+                </a:solidFill>
+                <a:effectLst/>
+                <a:latin typeface="+mn-lt"/>
+                <a:cs typeface="Times New Roman" panose="02020603050405020304" pitchFamily="18" charset="0"/>
+              </a:rPr>
+              <a:t>) к вам в папку </a:t>
+            </a:r>
+            <a:endParaRPr lang="en-US" sz="3600" dirty="0">
+              <a:solidFill>
+                <a:schemeClr val="tx1"/>
+              </a:solidFill>
+              <a:latin typeface="+mn-lt"/>
+              <a:cs typeface="Times New Roman" panose="02020603050405020304" pitchFamily="18" charset="0"/>
+            </a:endParaRPr>
+          </a:p>
+          <a:p>
+            <a:pPr marL="0" indent="0">
+              <a:buNone/>
+            </a:pPr>
+            <a:endParaRPr lang="ru-RU" sz="3600" dirty="0">
+              <a:solidFill>
+                <a:schemeClr val="tx1"/>
+              </a:solidFill>
+              <a:effectLst/>
+              <a:latin typeface="+mn-lt"/>
+              <a:cs typeface="Times New Roman" panose="02020603050405020304" pitchFamily="18" charset="0"/>
+            </a:endParaRPr>
+          </a:p>
+          <a:p>
+            <a:pPr marL="0" indent="0">
+              <a:buNone/>
+            </a:pPr>
+            <a:r>
+              <a:rPr lang="en" sz="3600" b="1" dirty="0">
+                <a:solidFill>
+                  <a:schemeClr val="tx1"/>
+                </a:solidFill>
+                <a:effectLst/>
+                <a:latin typeface="+mn-lt"/>
+                <a:cs typeface="Times New Roman" panose="02020603050405020304" pitchFamily="18" charset="0"/>
+              </a:rPr>
+              <a:t>git status </a:t>
+            </a:r>
+            <a:endParaRPr lang="ru-RU" sz="3600" b="1" dirty="0">
+              <a:solidFill>
+                <a:schemeClr val="tx1"/>
+              </a:solidFill>
+              <a:effectLst/>
+              <a:latin typeface="+mn-lt"/>
+              <a:cs typeface="Times New Roman" panose="02020603050405020304" pitchFamily="18" charset="0"/>
+            </a:endParaRPr>
+          </a:p>
+          <a:p>
+            <a:pPr marL="0" indent="0">
+              <a:buNone/>
+            </a:pPr>
+            <a:r>
+              <a:rPr lang="ru-RU" sz="3600" dirty="0">
+                <a:solidFill>
+                  <a:schemeClr val="tx1"/>
+                </a:solidFill>
+                <a:effectLst/>
+                <a:latin typeface="+mn-lt"/>
+                <a:cs typeface="Times New Roman" panose="02020603050405020304" pitchFamily="18" charset="0"/>
+              </a:rPr>
+              <a:t>Выводит статус </a:t>
+            </a:r>
+            <a:r>
+              <a:rPr lang="ru-RU" sz="3600" dirty="0" err="1">
+                <a:solidFill>
+                  <a:schemeClr val="tx1"/>
+                </a:solidFill>
+                <a:effectLst/>
+                <a:latin typeface="+mn-lt"/>
+                <a:cs typeface="Times New Roman" panose="02020603050405020304" pitchFamily="18" charset="0"/>
+              </a:rPr>
+              <a:t>репозитория</a:t>
+            </a:r>
+            <a:r>
+              <a:rPr lang="ru-RU" sz="3600" dirty="0">
+                <a:solidFill>
+                  <a:schemeClr val="tx1"/>
+                </a:solidFill>
+                <a:effectLst/>
+                <a:latin typeface="+mn-lt"/>
+                <a:cs typeface="Times New Roman" panose="02020603050405020304" pitchFamily="18" charset="0"/>
+              </a:rPr>
+              <a:t> </a:t>
+            </a:r>
+          </a:p>
+          <a:p>
+            <a:pPr marL="0" indent="0">
+              <a:buNone/>
+            </a:pPr>
+            <a:endParaRPr lang="en-US" sz="3600" dirty="0">
+              <a:solidFill>
+                <a:schemeClr val="tx1"/>
+              </a:solidFill>
+              <a:effectLst/>
+              <a:latin typeface="+mn-lt"/>
+              <a:cs typeface="Times New Roman" panose="02020603050405020304" pitchFamily="18" charset="0"/>
+            </a:endParaRPr>
+          </a:p>
+          <a:p>
+            <a:pPr marL="0" indent="0">
+              <a:buNone/>
+            </a:pPr>
+            <a:r>
+              <a:rPr lang="en" sz="3600" b="1" dirty="0">
+                <a:solidFill>
+                  <a:schemeClr val="tx1"/>
+                </a:solidFill>
+                <a:effectLst/>
+                <a:latin typeface="+mn-lt"/>
+                <a:cs typeface="Times New Roman" panose="02020603050405020304" pitchFamily="18" charset="0"/>
+              </a:rPr>
+              <a:t>git branch </a:t>
+            </a:r>
+            <a:endParaRPr lang="en" sz="3600" dirty="0">
+              <a:solidFill>
+                <a:schemeClr val="tx1"/>
+              </a:solidFill>
+              <a:effectLst/>
+              <a:latin typeface="+mn-lt"/>
+              <a:cs typeface="Times New Roman" panose="02020603050405020304" pitchFamily="18" charset="0"/>
+            </a:endParaRPr>
+          </a:p>
+          <a:p>
+            <a:pPr marL="0" indent="0">
+              <a:buNone/>
+            </a:pPr>
+            <a:r>
+              <a:rPr lang="ru-RU" sz="3600" dirty="0">
+                <a:solidFill>
+                  <a:schemeClr val="tx1"/>
+                </a:solidFill>
+                <a:effectLst/>
+                <a:latin typeface="+mn-lt"/>
+                <a:cs typeface="Times New Roman" panose="02020603050405020304" pitchFamily="18" charset="0"/>
+              </a:rPr>
+              <a:t>Выводит существующие ветки. Если написать после </a:t>
+            </a:r>
+            <a:r>
+              <a:rPr lang="en" sz="3600" dirty="0">
+                <a:solidFill>
+                  <a:schemeClr val="tx1"/>
+                </a:solidFill>
+                <a:effectLst/>
+                <a:latin typeface="+mn-lt"/>
+                <a:cs typeface="Times New Roman" panose="02020603050405020304" pitchFamily="18" charset="0"/>
+              </a:rPr>
+              <a:t>branch </a:t>
+            </a:r>
+            <a:r>
+              <a:rPr lang="ru-RU" sz="3600" dirty="0">
+                <a:solidFill>
+                  <a:schemeClr val="tx1"/>
+                </a:solidFill>
+                <a:effectLst/>
+                <a:latin typeface="+mn-lt"/>
+                <a:cs typeface="Times New Roman" panose="02020603050405020304" pitchFamily="18" charset="0"/>
+              </a:rPr>
+              <a:t>название, то вы создадите ветвь с таким названием </a:t>
+            </a:r>
+          </a:p>
+          <a:p>
+            <a:pPr marL="0" indent="0">
+              <a:buNone/>
+            </a:pPr>
+            <a:endParaRPr lang="ru-RU" sz="3600" dirty="0">
+              <a:solidFill>
+                <a:schemeClr val="tx1"/>
+              </a:solidFill>
+              <a:latin typeface="+mn-lt"/>
+              <a:cs typeface="Times New Roman" panose="02020603050405020304" pitchFamily="18" charset="0"/>
+            </a:endParaRPr>
+          </a:p>
+          <a:p>
+            <a:pPr marL="0" indent="0">
+              <a:buNone/>
+            </a:pPr>
+            <a:r>
+              <a:rPr lang="en" sz="3600" b="1" dirty="0">
+                <a:solidFill>
+                  <a:schemeClr val="tx1"/>
+                </a:solidFill>
+                <a:latin typeface="+mn-lt"/>
+                <a:cs typeface="Times New Roman" panose="02020603050405020304" pitchFamily="18" charset="0"/>
+              </a:rPr>
+              <a:t>g</a:t>
+            </a:r>
+            <a:r>
+              <a:rPr lang="en-US" sz="3600" b="1" dirty="0">
+                <a:solidFill>
+                  <a:schemeClr val="tx1"/>
+                </a:solidFill>
+                <a:latin typeface="+mn-lt"/>
+                <a:cs typeface="Times New Roman" panose="02020603050405020304" pitchFamily="18" charset="0"/>
+              </a:rPr>
+              <a:t>it checkout &lt;your branch&gt;</a:t>
+            </a:r>
+            <a:endParaRPr lang="ru-RU" sz="3600" b="1" dirty="0">
+              <a:solidFill>
+                <a:schemeClr val="tx1"/>
+              </a:solidFill>
+              <a:latin typeface="+mn-lt"/>
+              <a:cs typeface="Times New Roman" panose="02020603050405020304" pitchFamily="18" charset="0"/>
+            </a:endParaRPr>
+          </a:p>
+          <a:p>
+            <a:pPr marL="0" indent="0">
+              <a:buNone/>
+            </a:pPr>
+            <a:r>
+              <a:rPr lang="ru-RU" sz="3600" dirty="0">
+                <a:solidFill>
+                  <a:schemeClr val="tx1"/>
+                </a:solidFill>
+                <a:effectLst/>
+                <a:latin typeface="+mn-lt"/>
+                <a:cs typeface="Times New Roman" panose="02020603050405020304" pitchFamily="18" charset="0"/>
+              </a:rPr>
+              <a:t>Перемещает вас в указанную после </a:t>
+            </a:r>
+            <a:r>
+              <a:rPr lang="en" sz="3600" dirty="0">
+                <a:solidFill>
+                  <a:schemeClr val="tx1"/>
+                </a:solidFill>
+                <a:effectLst/>
+                <a:latin typeface="+mn-lt"/>
+                <a:cs typeface="Times New Roman" panose="02020603050405020304" pitchFamily="18" charset="0"/>
+              </a:rPr>
+              <a:t>checkout </a:t>
+            </a:r>
+            <a:r>
+              <a:rPr lang="ru-RU" sz="3600" dirty="0">
+                <a:solidFill>
+                  <a:schemeClr val="tx1"/>
+                </a:solidFill>
+                <a:effectLst/>
+                <a:latin typeface="+mn-lt"/>
+                <a:cs typeface="Times New Roman" panose="02020603050405020304" pitchFamily="18" charset="0"/>
+              </a:rPr>
+              <a:t>ветвь </a:t>
+            </a:r>
+            <a:endParaRPr lang="ru-RU" sz="3600" b="1" dirty="0">
+              <a:solidFill>
+                <a:schemeClr val="tx1"/>
+              </a:solidFill>
+              <a:effectLst/>
+              <a:latin typeface="+mn-lt"/>
+              <a:cs typeface="Times New Roman" panose="02020603050405020304" pitchFamily="18" charset="0"/>
+            </a:endParaRPr>
+          </a:p>
+          <a:p>
+            <a:pPr marL="0" indent="0">
+              <a:buNone/>
+            </a:pPr>
+            <a:endParaRPr lang="en-US" sz="3600" dirty="0">
+              <a:solidFill>
+                <a:schemeClr val="tx1"/>
+              </a:solidFill>
+              <a:effectLst/>
+              <a:latin typeface="+mn-lt"/>
+              <a:cs typeface="Times New Roman" panose="02020603050405020304" pitchFamily="18" charset="0"/>
+            </a:endParaRPr>
+          </a:p>
+          <a:p>
+            <a:pPr marL="0" indent="0">
+              <a:buNone/>
+            </a:pPr>
+            <a:r>
+              <a:rPr lang="en" sz="3600" b="1" dirty="0">
+                <a:solidFill>
+                  <a:schemeClr val="tx1"/>
+                </a:solidFill>
+                <a:effectLst/>
+                <a:latin typeface="+mn-lt"/>
+                <a:cs typeface="Times New Roman" panose="02020603050405020304" pitchFamily="18" charset="0"/>
+              </a:rPr>
+              <a:t>git add</a:t>
+            </a:r>
+            <a:endParaRPr lang="ru-RU" sz="3600" b="1" dirty="0">
+              <a:solidFill>
+                <a:schemeClr val="tx1"/>
+              </a:solidFill>
+              <a:effectLst/>
+              <a:latin typeface="+mn-lt"/>
+              <a:cs typeface="Times New Roman" panose="02020603050405020304" pitchFamily="18" charset="0"/>
+            </a:endParaRPr>
+          </a:p>
+          <a:p>
+            <a:pPr marL="0" indent="0">
+              <a:buNone/>
+            </a:pPr>
+            <a:r>
+              <a:rPr lang="ru-RU" sz="3600" dirty="0">
+                <a:solidFill>
+                  <a:schemeClr val="tx1"/>
+                </a:solidFill>
+                <a:effectLst/>
+                <a:latin typeface="+mn-lt"/>
+                <a:cs typeface="Times New Roman" panose="02020603050405020304" pitchFamily="18" charset="0"/>
+              </a:rPr>
+              <a:t>Добавляет </a:t>
+            </a:r>
+            <a:r>
+              <a:rPr lang="ru-RU" sz="3600" dirty="0" err="1">
+                <a:solidFill>
+                  <a:schemeClr val="tx1"/>
+                </a:solidFill>
+                <a:effectLst/>
+                <a:latin typeface="+mn-lt"/>
+                <a:cs typeface="Times New Roman" panose="02020603050405020304" pitchFamily="18" charset="0"/>
+              </a:rPr>
+              <a:t>файл</a:t>
+            </a:r>
+            <a:r>
+              <a:rPr lang="ru-RU" sz="3600" dirty="0">
+                <a:solidFill>
+                  <a:schemeClr val="tx1"/>
+                </a:solidFill>
+                <a:effectLst/>
+                <a:latin typeface="+mn-lt"/>
+                <a:cs typeface="Times New Roman" panose="02020603050405020304" pitchFamily="18" charset="0"/>
+              </a:rPr>
+              <a:t>, </a:t>
+            </a:r>
+            <a:r>
+              <a:rPr lang="ru-RU" sz="3600" dirty="0" err="1">
+                <a:solidFill>
+                  <a:schemeClr val="tx1"/>
+                </a:solidFill>
+                <a:effectLst/>
+                <a:latin typeface="+mn-lt"/>
+                <a:cs typeface="Times New Roman" panose="02020603050405020304" pitchFamily="18" charset="0"/>
+              </a:rPr>
+              <a:t>указанныи</a:t>
+            </a:r>
+            <a:r>
+              <a:rPr lang="ru-RU" sz="3600" dirty="0">
+                <a:solidFill>
+                  <a:schemeClr val="tx1"/>
+                </a:solidFill>
+                <a:effectLst/>
+                <a:latin typeface="+mn-lt"/>
+                <a:cs typeface="Times New Roman" panose="02020603050405020304" pitchFamily="18" charset="0"/>
+              </a:rPr>
+              <a:t>̆ после </a:t>
+            </a:r>
+            <a:r>
+              <a:rPr lang="en" sz="3600" dirty="0">
+                <a:solidFill>
+                  <a:schemeClr val="tx1"/>
+                </a:solidFill>
+                <a:effectLst/>
+                <a:latin typeface="+mn-lt"/>
+                <a:cs typeface="Times New Roman" panose="02020603050405020304" pitchFamily="18" charset="0"/>
+              </a:rPr>
+              <a:t>add, </a:t>
+            </a:r>
+            <a:r>
+              <a:rPr lang="ru-RU" sz="3600" dirty="0">
+                <a:solidFill>
+                  <a:schemeClr val="tx1"/>
+                </a:solidFill>
+                <a:effectLst/>
+                <a:latin typeface="+mn-lt"/>
+                <a:cs typeface="Times New Roman" panose="02020603050405020304" pitchFamily="18" charset="0"/>
+              </a:rPr>
+              <a:t>в рассмотрение на </a:t>
+            </a:r>
+            <a:r>
+              <a:rPr lang="ru-RU" sz="3600" dirty="0" err="1">
+                <a:solidFill>
+                  <a:schemeClr val="tx1"/>
+                </a:solidFill>
+                <a:effectLst/>
+                <a:latin typeface="+mn-lt"/>
+                <a:cs typeface="Times New Roman" panose="02020603050405020304" pitchFamily="18" charset="0"/>
+              </a:rPr>
+              <a:t>коммит</a:t>
+            </a:r>
+            <a:r>
+              <a:rPr lang="ru-RU" sz="3600" dirty="0">
+                <a:solidFill>
+                  <a:schemeClr val="tx1"/>
+                </a:solidFill>
+                <a:effectLst/>
+                <a:latin typeface="+mn-lt"/>
+                <a:cs typeface="Times New Roman" panose="02020603050405020304" pitchFamily="18" charset="0"/>
+              </a:rPr>
+              <a:t> </a:t>
+            </a:r>
+            <a:r>
+              <a:rPr lang="en-US" sz="3600" dirty="0">
+                <a:solidFill>
+                  <a:schemeClr val="tx1"/>
+                </a:solidFill>
+                <a:effectLst/>
+                <a:latin typeface="+mn-lt"/>
+                <a:cs typeface="Times New Roman" panose="02020603050405020304" pitchFamily="18" charset="0"/>
+              </a:rPr>
+              <a:t> (</a:t>
+            </a:r>
+            <a:r>
+              <a:rPr lang="en-US" sz="3600" dirty="0" err="1">
+                <a:solidFill>
+                  <a:schemeClr val="tx1"/>
+                </a:solidFill>
+                <a:effectLst/>
+                <a:latin typeface="+mn-lt"/>
+                <a:cs typeface="Times New Roman" panose="02020603050405020304" pitchFamily="18" charset="0"/>
+              </a:rPr>
+              <a:t>с</a:t>
+            </a:r>
+            <a:r>
+              <a:rPr lang="ru-RU" sz="3600" dirty="0" err="1">
+                <a:solidFill>
+                  <a:schemeClr val="tx1"/>
+                </a:solidFill>
+                <a:effectLst/>
+                <a:latin typeface="+mn-lt"/>
+                <a:cs typeface="Times New Roman" panose="02020603050405020304" pitchFamily="18" charset="0"/>
+              </a:rPr>
+              <a:t>имвол</a:t>
+            </a:r>
+            <a:r>
+              <a:rPr lang="ru-RU" sz="3600" dirty="0">
+                <a:solidFill>
+                  <a:schemeClr val="tx1"/>
+                </a:solidFill>
+                <a:effectLst/>
+                <a:latin typeface="+mn-lt"/>
+                <a:cs typeface="Times New Roman" panose="02020603050405020304" pitchFamily="18" charset="0"/>
+              </a:rPr>
+              <a:t> .</a:t>
+            </a:r>
+            <a:r>
+              <a:rPr lang="en-US" sz="3600" dirty="0">
+                <a:solidFill>
+                  <a:schemeClr val="tx1"/>
+                </a:solidFill>
+                <a:effectLst/>
+                <a:latin typeface="+mn-lt"/>
+                <a:cs typeface="Times New Roman" panose="02020603050405020304" pitchFamily="18" charset="0"/>
+              </a:rPr>
+              <a:t> </a:t>
+            </a:r>
+            <a:r>
+              <a:rPr lang="ru-RU" sz="3600" dirty="0">
+                <a:solidFill>
+                  <a:schemeClr val="tx1"/>
+                </a:solidFill>
+                <a:effectLst/>
+                <a:latin typeface="+mn-lt"/>
+                <a:cs typeface="Times New Roman" panose="02020603050405020304" pitchFamily="18" charset="0"/>
+              </a:rPr>
+              <a:t>Добавляет все измененные файлы)</a:t>
+            </a:r>
+          </a:p>
+          <a:p>
+            <a:pPr marL="0" indent="0">
+              <a:buNone/>
+            </a:pPr>
+            <a:endParaRPr lang="ru-RU" sz="3600" dirty="0">
+              <a:solidFill>
+                <a:schemeClr val="tx1"/>
+              </a:solidFill>
+              <a:latin typeface="+mn-lt"/>
+              <a:ea typeface="Tahoma" panose="020B0604030504040204" pitchFamily="34" charset="0"/>
+              <a:cs typeface="Times New Roman" panose="02020603050405020304" pitchFamily="18" charset="0"/>
+            </a:endParaRPr>
+          </a:p>
+        </p:txBody>
+      </p:sp>
+      <p:sp>
+        <p:nvSpPr>
+          <p:cNvPr id="18" name="Номер слайда 17"/>
           <p:cNvSpPr>
             <a:spLocks noGrp="1"/>
           </p:cNvSpPr>
@@ -15274,226 +15436,10 @@
           </a:p>
         </p:txBody>
       </p:sp>
-      <p:pic>
-        <p:nvPicPr>
-          <p:cNvPr id="2050" name="Picture 2">
-            <a:extLst>
-              <a:ext uri="{FF2B5EF4-FFF2-40B4-BE49-F238E27FC236}">
-                <a16:creationId xmlns:a16="http://schemas.microsoft.com/office/drawing/2014/main" id="{6C6820FC-35C4-103A-4478-A5270D21CEE3}"/>
-              </a:ext>
-            </a:extLst>
-          </p:cNvPr>
-          <p:cNvPicPr>
-            <a:picLocks noChangeAspect="1" noChangeArrowheads="1"/>
-          </p:cNvPicPr>
-          <p:nvPr/>
-        </p:nvPicPr>
-        <p:blipFill>
-          <a:blip r:embed="rId2">
-            <a:extLst>
-              <a:ext uri="{28A0092B-C50C-407E-A947-70E740481C1C}">
-                <a14:useLocalDpi xmlns:a14="http://schemas.microsoft.com/office/drawing/2010/main" val="0"/>
-              </a:ext>
-            </a:extLst>
-          </a:blip>
-          <a:srcRect/>
-          <a:stretch>
-            <a:fillRect/>
-          </a:stretch>
-        </p:blipFill>
-        <p:spPr bwMode="auto">
-          <a:xfrm>
-            <a:off x="13740000" y="4123265"/>
-            <a:ext cx="6307667" cy="6307667"/>
-          </a:xfrm>
-          <a:prstGeom prst="rect">
-            <a:avLst/>
-          </a:prstGeom>
-          <a:noFill/>
-          <a:extLst>
-            <a:ext uri="{909E8E84-426E-40DD-AFC4-6F175D3DCCD1}">
-              <a14:hiddenFill xmlns:a14="http://schemas.microsoft.com/office/drawing/2010/main">
-                <a:solidFill>
-                  <a:srgbClr val="FFFFFF"/>
-                </a:solidFill>
-              </a14:hiddenFill>
-            </a:ext>
-          </a:extLst>
-        </p:spPr>
-      </p:pic>
-      <p:pic>
-        <p:nvPicPr>
-          <p:cNvPr id="3" name="Рисунок 2" descr="Изображение выглядит как шаблон, пиксель, дизайн&#10;&#10;Автоматически созданное описание">
-            <a:extLst>
-              <a:ext uri="{FF2B5EF4-FFF2-40B4-BE49-F238E27FC236}">
-                <a16:creationId xmlns:a16="http://schemas.microsoft.com/office/drawing/2014/main" id="{1581A2F8-C549-441B-D6F1-B4E77516ECC3}"/>
-              </a:ext>
-            </a:extLst>
-          </p:cNvPr>
-          <p:cNvPicPr>
-            <a:picLocks noChangeAspect="1"/>
-          </p:cNvPicPr>
-          <p:nvPr/>
-        </p:nvPicPr>
-        <p:blipFill>
-          <a:blip r:embed="rId3">
-            <a:extLst>
-              <a:ext uri="{28A0092B-C50C-407E-A947-70E740481C1C}">
-                <a14:useLocalDpi xmlns:a14="http://schemas.microsoft.com/office/drawing/2010/main" val="0"/>
-              </a:ext>
-            </a:extLst>
-          </a:blip>
-          <a:stretch>
-            <a:fillRect/>
-          </a:stretch>
-        </p:blipFill>
-        <p:spPr>
-          <a:xfrm>
-            <a:off x="3437467" y="4103734"/>
-            <a:ext cx="6307667" cy="6307667"/>
-          </a:xfrm>
-          <a:prstGeom prst="rect">
-            <a:avLst/>
-          </a:prstGeom>
-        </p:spPr>
-      </p:pic>
-      <p:sp>
-        <p:nvSpPr>
-          <p:cNvPr id="4" name="Заголовок 11">
-            <a:extLst>
-              <a:ext uri="{FF2B5EF4-FFF2-40B4-BE49-F238E27FC236}">
-                <a16:creationId xmlns:a16="http://schemas.microsoft.com/office/drawing/2014/main" id="{75EAA36C-1EFB-9471-97B9-24B3FAAE98F1}"/>
-              </a:ext>
-            </a:extLst>
-          </p:cNvPr>
-          <p:cNvSpPr txBox="1">
-            <a:spLocks/>
-          </p:cNvSpPr>
-          <p:nvPr/>
-        </p:nvSpPr>
-        <p:spPr>
-          <a:xfrm>
-            <a:off x="13010159" y="10575535"/>
-            <a:ext cx="14754286" cy="1103759"/>
-          </a:xfrm>
-          <a:prstGeom prst="rect">
-            <a:avLst/>
-          </a:prstGeom>
-        </p:spPr>
-        <p:txBody>
-          <a:bodyPr vert="horz" lIns="91440" tIns="45720" rIns="91440" bIns="45720" rtlCol="0" anchor="t">
-            <a:noAutofit/>
-          </a:bodyPr>
-          <a:lstStyle>
-            <a:lvl1pPr algn="l" defTabSz="1828709" rtl="0" eaLnBrk="1" latinLnBrk="0" hangingPunct="1">
-              <a:lnSpc>
-                <a:spcPts val="6700"/>
-              </a:lnSpc>
-              <a:spcBef>
-                <a:spcPct val="0"/>
-              </a:spcBef>
-              <a:buNone/>
-              <a:defRPr sz="7300" kern="1200">
-                <a:solidFill>
-                  <a:schemeClr val="accent1"/>
-                </a:solidFill>
-                <a:latin typeface="+mj-lt"/>
-                <a:ea typeface="+mj-ea"/>
-                <a:cs typeface="+mj-cs"/>
-              </a:defRPr>
-            </a:lvl1pPr>
-          </a:lstStyle>
-          <a:p>
-            <a:r>
-              <a:rPr lang="ru-RU" sz="7200" b="1" dirty="0">
-                <a:latin typeface="Tahoma" panose="020B0604030504040204" pitchFamily="34" charset="0"/>
-                <a:ea typeface="Tahoma" panose="020B0604030504040204" pitchFamily="34" charset="0"/>
-                <a:cs typeface="Tahoma" panose="020B0604030504040204" pitchFamily="34" charset="0"/>
-              </a:rPr>
-              <a:t>Ссылка на опрос</a:t>
-            </a:r>
-          </a:p>
-        </p:txBody>
-      </p:sp>
-      <p:sp>
-        <p:nvSpPr>
-          <p:cNvPr id="5" name="Заголовок 11">
-            <a:extLst>
-              <a:ext uri="{FF2B5EF4-FFF2-40B4-BE49-F238E27FC236}">
-                <a16:creationId xmlns:a16="http://schemas.microsoft.com/office/drawing/2014/main" id="{49E615E8-1266-D5E9-04E9-0FBA54034836}"/>
-              </a:ext>
-            </a:extLst>
-          </p:cNvPr>
-          <p:cNvSpPr txBox="1">
-            <a:spLocks/>
-          </p:cNvSpPr>
-          <p:nvPr/>
-        </p:nvSpPr>
-        <p:spPr>
-          <a:xfrm>
-            <a:off x="-785843" y="10562168"/>
-            <a:ext cx="14754286" cy="1103759"/>
-          </a:xfrm>
-          <a:prstGeom prst="rect">
-            <a:avLst/>
-          </a:prstGeom>
-        </p:spPr>
-        <p:txBody>
-          <a:bodyPr vert="horz" lIns="91440" tIns="45720" rIns="91440" bIns="45720" rtlCol="0" anchor="t">
-            <a:noAutofit/>
-          </a:bodyPr>
-          <a:lstStyle>
-            <a:lvl1pPr algn="l" defTabSz="1828709" rtl="0" eaLnBrk="1" latinLnBrk="0" hangingPunct="1">
-              <a:lnSpc>
-                <a:spcPts val="6700"/>
-              </a:lnSpc>
-              <a:spcBef>
-                <a:spcPct val="0"/>
-              </a:spcBef>
-              <a:buNone/>
-              <a:defRPr sz="7300" kern="1200">
-                <a:solidFill>
-                  <a:schemeClr val="accent1"/>
-                </a:solidFill>
-                <a:latin typeface="+mj-lt"/>
-                <a:ea typeface="+mj-ea"/>
-                <a:cs typeface="+mj-cs"/>
-              </a:defRPr>
-            </a:lvl1pPr>
-          </a:lstStyle>
-          <a:p>
-            <a:pPr algn="ctr"/>
-            <a:r>
-              <a:rPr lang="ru-RU" sz="7200" b="1" dirty="0">
-                <a:latin typeface="Tahoma" panose="020B0604030504040204" pitchFamily="34" charset="0"/>
-                <a:ea typeface="Tahoma" panose="020B0604030504040204" pitchFamily="34" charset="0"/>
-                <a:cs typeface="Tahoma" panose="020B0604030504040204" pitchFamily="34" charset="0"/>
-              </a:rPr>
-              <a:t>Ссылка </a:t>
-            </a:r>
-            <a:r>
-              <a:rPr lang="en-US" sz="7200" b="1" dirty="0" err="1">
-                <a:latin typeface="Tahoma" panose="020B0604030504040204" pitchFamily="34" charset="0"/>
-                <a:ea typeface="Tahoma" panose="020B0604030504040204" pitchFamily="34" charset="0"/>
-                <a:cs typeface="Tahoma" panose="020B0604030504040204" pitchFamily="34" charset="0"/>
-              </a:rPr>
-              <a:t>н</a:t>
-            </a:r>
-            <a:r>
-              <a:rPr lang="ru-RU" sz="7200" b="1" dirty="0">
-                <a:latin typeface="Tahoma" panose="020B0604030504040204" pitchFamily="34" charset="0"/>
-                <a:ea typeface="Tahoma" panose="020B0604030504040204" pitchFamily="34" charset="0"/>
-                <a:cs typeface="Tahoma" panose="020B0604030504040204" pitchFamily="34" charset="0"/>
-              </a:rPr>
-              <a:t>а чат</a:t>
-            </a:r>
-          </a:p>
-        </p:txBody>
-      </p:sp>
     </p:spTree>
     <p:extLst>
       <p:ext uri="{BB962C8B-B14F-4D97-AF65-F5344CB8AC3E}">
-        <p14:creationId xmlns:p14="http://schemas.microsoft.com/office/powerpoint/2010/main" val="1174464176"/>
+        <p14:creationId xmlns:p14="http://schemas.microsoft.com/office/powerpoint/2010/main" val="571222784"/>
       </p:ext>
     </p:extLst>
   </p:cSld>
@@ -15612,9 +15558,20 @@
                 <a:latin typeface="+mn-lt"/>
                 <a:cs typeface="Times New Roman" panose="02020603050405020304" pitchFamily="18" charset="0"/>
               </a:rPr>
-              <a:t>git clone link</a:t>
-            </a:r>
-            <a:endParaRPr lang="ru-RU" sz="3600" b="1" dirty="0">
+              <a:t>git commit </a:t>
+            </a:r>
+            <a:r>
+              <a:rPr lang="en-US" sz="3600" b="1" dirty="0">
+                <a:solidFill>
+                  <a:schemeClr val="tx1"/>
+                </a:solidFill>
+                <a:effectLst/>
+                <a:latin typeface="+mn-lt"/>
+                <a:cs typeface="Times New Roman" panose="02020603050405020304" pitchFamily="18" charset="0"/>
+              </a:rPr>
+              <a:t>–m “commit comment”</a:t>
+            </a:r>
+            <a:endParaRPr lang="en" sz="3600" dirty="0">
               <a:solidFill>
                 <a:schemeClr val="tx1"/>
               </a:solidFill>
@@ -15628,6 +15585,17 @@
               <a:buNone/>
             </a:pPr>
             <a:r>
+              <a:rPr lang="ru-RU" sz="3600" dirty="0" err="1">
+                <a:solidFill>
+                  <a:schemeClr val="tx1"/>
+                </a:solidFill>
+                <a:effectLst/>
+                <a:latin typeface="+mn-lt"/>
+                <a:cs typeface="Times New Roman" panose="02020603050405020304" pitchFamily="18" charset="0"/>
+              </a:rPr>
+              <a:t>Коммитит</a:t>
+            </a:r>
+            <a:r>
               <a:rPr lang="ru-RU" sz="3600" dirty="0">
                 <a:solidFill>
                   <a:schemeClr val="tx1"/>
@@ -15636,7 +15604,18 @@
                 <a:latin typeface="+mn-lt"/>
                 <a:cs typeface="Times New Roman" panose="02020603050405020304" pitchFamily="18" charset="0"/>
               </a:rPr>
-              <a:t>Клонирует </a:t>
+              <a:t> добавленные </a:t>
+            </a:r>
+            <a:r>
+              <a:rPr lang="en" sz="3600" dirty="0">
+                <a:solidFill>
+                  <a:schemeClr val="tx1"/>
+                </a:solidFill>
+                <a:effectLst/>
+                <a:latin typeface="+mn-lt"/>
+                <a:cs typeface="Times New Roman" panose="02020603050405020304" pitchFamily="18" charset="0"/>
+              </a:rPr>
+              <a:t>git add </a:t>
             </a:r>
             <a:r>
               <a:rPr lang="ru-RU" sz="3600" dirty="0" err="1">
@@ -15647,7 +15626,7 @@
                 <a:latin typeface="+mn-lt"/>
                 <a:cs typeface="Times New Roman" panose="02020603050405020304" pitchFamily="18" charset="0"/>
               </a:rPr>
-              <a:t>репозитории</a:t>
+              <a:t>файлы</a:t>
             </a:r>
             <a:r>
               <a:rPr lang="ru-RU" sz="3600" dirty="0">
@@ -15658,7 +15637,23 @@
                 <a:latin typeface="+mn-lt"/>
                 <a:cs typeface="Times New Roman" panose="02020603050405020304" pitchFamily="18" charset="0"/>
               </a:rPr>
-              <a:t>̆ </a:t>
+              <a:t> </a:t>
+            </a:r>
+          </a:p>
+          <a:p>
+            <a:pPr marL="0" indent="0">
+              <a:buNone/>
+            </a:pPr>
+            <a:r>
+              <a:rPr lang="ru-RU" sz="3600" dirty="0">
+                <a:solidFill>
+                  <a:schemeClr val="tx1"/>
+                </a:solidFill>
+                <a:effectLst/>
+                <a:latin typeface="+mn-lt"/>
+                <a:cs typeface="Times New Roman" panose="02020603050405020304" pitchFamily="18" charset="0"/>
+              </a:rPr>
+              <a:t>В пишется комментарий к </a:t>
             </a:r>
             <a:r>
               <a:rPr lang="ru-RU" sz="3600" dirty="0" err="1">
@@ -15669,7 +15664,7 @@
                 <a:latin typeface="+mn-lt"/>
                 <a:cs typeface="Times New Roman" panose="02020603050405020304" pitchFamily="18" charset="0"/>
               </a:rPr>
-              <a:t>ссервера</a:t>
+              <a:t>коммиту</a:t>
             </a:r>
             <a:r>
               <a:rPr lang="ru-RU" sz="3600" dirty="0">
@@ -15680,35 +15675,19 @@
                 <a:latin typeface="+mn-lt"/>
                 <a:cs typeface="Times New Roman" panose="02020603050405020304" pitchFamily="18" charset="0"/>
               </a:rPr>
-              <a:t> (</a:t>
-            </a:r>
-            <a:r>
-              <a:rPr lang="ru-RU" sz="3600" dirty="0" err="1">
-                <a:solidFill>
-                  <a:schemeClr val="tx1"/>
-                </a:solidFill>
-                <a:effectLst/>
-                <a:latin typeface="+mn-lt"/>
-                <a:cs typeface="Times New Roman" panose="02020603050405020304" pitchFamily="18" charset="0"/>
-              </a:rPr>
-              <a:t>сайта</a:t>
-            </a:r>
-            <a:r>
-              <a:rPr lang="ru-RU" sz="3600" dirty="0">
-                <a:solidFill>
-                  <a:schemeClr val="tx1"/>
-                </a:solidFill>
-                <a:effectLst/>
-                <a:latin typeface="+mn-lt"/>
-                <a:cs typeface="Times New Roman" panose="02020603050405020304" pitchFamily="18" charset="0"/>
-              </a:rPr>
-              <a:t>) к вам в папку </a:t>
-            </a:r>
+              <a:t> </a:t>
+            </a:r>
+          </a:p>
+          <a:p>
+            <a:pPr marL="0" indent="0">
+              <a:buNone/>
+            </a:pPr>
             <a:endParaRPr lang="en-US" sz="3600" dirty="0">
               <a:solidFill>
                 <a:schemeClr val="tx1"/>
               </a:solidFill>
               <a:latin typeface="+mn-lt"/>
+              <a:ea typeface="Tahoma" panose="020B0604030504040204" pitchFamily="34" charset="0"/>
               <a:cs typeface="Times New Roman" panose="02020603050405020304" pitchFamily="18" charset="0"/>
             </a:endParaRPr>
           </a:p>
@@ -15716,7 +15695,18 @@
             <a:pPr marL="0" indent="0">
               <a:buNone/>
             </a:pPr>
-            <a:endParaRPr lang="ru-RU" sz="3600" dirty="0">
+            <a:r>
+              <a:rPr lang="en" sz="3600" b="1" dirty="0">
+                <a:solidFill>
+                  <a:schemeClr val="tx1"/>
+                </a:solidFill>
+                <a:effectLst/>
+                <a:latin typeface="+mn-lt"/>
+                <a:cs typeface="Times New Roman" panose="02020603050405020304" pitchFamily="18" charset="0"/>
+              </a:rPr>
+              <a:t>git push  origin main</a:t>
+            </a:r>
+            <a:endParaRPr lang="en" sz="3600" dirty="0">
               <a:solidFill>
                 <a:schemeClr val="tx1"/>
               </a:solidFill>
@@ -15730,7 +15720,7 @@
               <a:buNone/>
             </a:pPr>
             <a:r>
-              <a:rPr lang="en" sz="3600" b="1" dirty="0">
+              <a:rPr lang="ru-RU" sz="3600" dirty="0">
                 <a:solidFill>
                   <a:schemeClr val="tx1"/>
                 </a:solidFill>
@@ -15738,21 +15728,19 @@
                 <a:latin typeface="+mn-lt"/>
                 <a:cs typeface="Times New Roman" panose="02020603050405020304" pitchFamily="18" charset="0"/>
               </a:rPr>
-              <a:t>git status </a:t>
-            </a:r>
-            <a:endParaRPr lang="ru-RU" sz="3600" b="1" dirty="0">
-              <a:solidFill>
-                <a:schemeClr val="tx1"/>
-              </a:solidFill>
-              <a:effectLst/>
-              <a:latin typeface="+mn-lt"/>
-              <a:cs typeface="Times New Roman" panose="02020603050405020304" pitchFamily="18" charset="0"/>
-            </a:endParaRPr>
-          </a:p>
-          <a:p>
-            <a:pPr marL="0" indent="0">
-              <a:buNone/>
-            </a:pPr>
+              <a:t>Закидывает </a:t>
+            </a:r>
+            <a:r>
+              <a:rPr lang="ru-RU" sz="3600" dirty="0" err="1">
+                <a:solidFill>
+                  <a:schemeClr val="tx1"/>
+                </a:solidFill>
+                <a:effectLst/>
+                <a:latin typeface="+mn-lt"/>
+                <a:cs typeface="Times New Roman" panose="02020603050405020304" pitchFamily="18" charset="0"/>
+              </a:rPr>
+              <a:t>закомиченныи</a:t>
+            </a:r>
             <a:r>
               <a:rPr lang="ru-RU" sz="3600" dirty="0">
                 <a:solidFill>
@@ -15762,7 +15750,7 @@
                 <a:latin typeface="+mn-lt"/>
                 <a:cs typeface="Times New Roman" panose="02020603050405020304" pitchFamily="18" charset="0"/>
               </a:rPr>
-              <a:t>Выводит статус </a:t>
+              <a:t>̆ код в </a:t>
             </a:r>
             <a:r>
               <a:rPr lang="ru-RU" sz="3600" dirty="0" err="1">
@@ -15773,7 +15761,7 @@
                 <a:latin typeface="+mn-lt"/>
                 <a:cs typeface="Times New Roman" panose="02020603050405020304" pitchFamily="18" charset="0"/>
               </a:rPr>
-              <a:t>репозитория</a:t>
+              <a:t>репозитории</a:t>
             </a:r>
             <a:r>
               <a:rPr lang="ru-RU" sz="3600" dirty="0">
@@ -15784,13 +15772,30 @@
                 <a:latin typeface="+mn-lt"/>
                 <a:cs typeface="Times New Roman" panose="02020603050405020304" pitchFamily="18" charset="0"/>
               </a:rPr>
-              <a:t> </a:t>
-            </a:r>
-          </a:p>
-          <a:p>
-            <a:pPr marL="0" indent="0">
-              <a:buNone/>
-            </a:pPr>
+              <a:t>̆. Сначала </a:t>
+            </a:r>
+            <a:r>
+              <a:rPr lang="ru-RU" sz="3600" dirty="0" err="1">
+                <a:solidFill>
+                  <a:schemeClr val="tx1"/>
+                </a:solidFill>
+                <a:effectLst/>
+                <a:latin typeface="+mn-lt"/>
+                <a:cs typeface="Times New Roman" panose="02020603050405020304" pitchFamily="18" charset="0"/>
+              </a:rPr>
+              <a:t>идёт</a:t>
+            </a:r>
+            <a:r>
+              <a:rPr lang="ru-RU" sz="3600" dirty="0">
+                <a:solidFill>
+                  <a:schemeClr val="tx1"/>
+                </a:solidFill>
+                <a:effectLst/>
+                <a:latin typeface="+mn-lt"/>
+                <a:cs typeface="Times New Roman" panose="02020603050405020304" pitchFamily="18" charset="0"/>
+              </a:rPr>
+              <a:t> место, куда вы пушите, а потом что вы пишите </a:t>
+            </a:r>
             <a:endParaRPr lang="en-US" sz="3600" dirty="0">
               <a:solidFill>
                 <a:schemeClr val="tx1"/>
@@ -15804,6 +15809,18 @@
             <a:pPr marL="0" indent="0">
               <a:buNone/>
             </a:pPr>
+            <a:endParaRPr lang="en-US" sz="3600" dirty="0">
+              <a:solidFill>
+                <a:schemeClr val="tx1"/>
+              </a:solidFill>
+              <a:latin typeface="+mn-lt"/>
+              <a:cs typeface="Times New Roman" panose="02020603050405020304" pitchFamily="18" charset="0"/>
+            </a:endParaRPr>
+          </a:p>
+          <a:p>
+            <a:pPr marL="0" indent="0">
+              <a:buNone/>
+            </a:pPr>
             <a:r>
               <a:rPr lang="en" sz="3600" b="1" dirty="0">
                 <a:solidFill>
@@ -15813,7 +15830,7 @@
                 <a:latin typeface="+mn-lt"/>
                 <a:cs typeface="Times New Roman" panose="02020603050405020304" pitchFamily="18" charset="0"/>
               </a:rPr>
-              <a:t>git branch </a:t>
+              <a:t>git pull </a:t>
             </a:r>
             <a:endParaRPr lang="en" sz="3600" dirty="0">
               <a:solidFill>
@@ -15837,10 +15854,10 @@
                 <a:latin typeface="+mn-lt"/>
                 <a:cs typeface="Times New Roman" panose="02020603050405020304" pitchFamily="18" charset="0"/>
               </a:rPr>
-              <a:t>Выводит существующие ветки. Если написать после </a:t>
-            </a:r>
-            <a:r>
-              <a:rPr lang="en" sz="3600" dirty="0">
+              <a:t>Стягивает к вам последние изменения в общепринятом состоянии </a:t>
+            </a:r>
+            <a:r>
+              <a:rPr lang="ru-RU" sz="3600" dirty="0" err="1">
                 <a:solidFill>
                   <a:schemeClr val="tx1"/>
                 </a:solidFill>
@@ -15848,7 +15865,7 @@
                 <a:latin typeface="+mn-lt"/>
                 <a:cs typeface="Times New Roman" panose="02020603050405020304" pitchFamily="18" charset="0"/>
               </a:rPr>
-              <a:t>branch </a:t>
+              <a:t>репозитория</a:t>
             </a:r>
             <a:r>
               <a:rPr lang="ru-RU" sz="3600" dirty="0">
@@ -15859,317 +15876,56 @@
                 <a:latin typeface="+mn-lt"/>
                 <a:cs typeface="Times New Roman" panose="02020603050405020304" pitchFamily="18" charset="0"/>
               </a:rPr>
-              <a:t>название, то вы создадите ветвь с таким названием </a:t>
+              <a:t> </a:t>
             </a:r>
           </a:p>
           <a:p>
             <a:pPr marL="0" indent="0">
               <a:buNone/>
             </a:pPr>
-            <a:endParaRPr lang="ru-RU" sz="3600" dirty="0">
-              <a:solidFill>
-                <a:schemeClr val="tx1"/>
-              </a:solidFill>
-              <a:latin typeface="+mn-lt"/>
-              <a:cs typeface="Times New Roman" panose="02020603050405020304" pitchFamily="18" charset="0"/>
-            </a:endParaRPr>
+            <a:r>
+              <a:rPr lang="en-US" sz="3600" dirty="0">
+                <a:solidFill>
+                  <a:schemeClr val="tx1"/>
+                </a:solidFill>
+                <a:effectLst/>
+                <a:latin typeface="+mn-lt"/>
+                <a:cs typeface="Times New Roman" panose="02020603050405020304" pitchFamily="18" charset="0"/>
+              </a:rPr>
+              <a:t>(</a:t>
+            </a:r>
+            <a:r>
+              <a:rPr lang="ru-RU" sz="3600" dirty="0">
+                <a:solidFill>
+                  <a:schemeClr val="tx1"/>
+                </a:solidFill>
+                <a:latin typeface="+mn-lt"/>
+                <a:cs typeface="Times New Roman" panose="02020603050405020304" pitchFamily="18" charset="0"/>
+              </a:rPr>
+              <a:t>* Б</a:t>
+            </a:r>
+            <a:r>
+              <a:rPr lang="ru-RU" sz="3600" dirty="0">
+                <a:solidFill>
+                  <a:schemeClr val="tx1"/>
+                </a:solidFill>
+                <a:effectLst/>
+                <a:latin typeface="+mn-lt"/>
+                <a:cs typeface="Times New Roman" panose="02020603050405020304" pitchFamily="18" charset="0"/>
+              </a:rPr>
+              <a:t>удьте внимательны!  Изменяет ваши файлы)</a:t>
+            </a:r>
           </a:p>
           <a:p>
             <a:pPr marL="0" indent="0">
               <a:buNone/>
             </a:pPr>
-            <a:r>
-              <a:rPr lang="en" sz="3600" b="1" dirty="0">
-                <a:solidFill>
-                  <a:schemeClr val="tx1"/>
-                </a:solidFill>
-                <a:latin typeface="+mn-lt"/>
-                <a:cs typeface="Times New Roman" panose="02020603050405020304" pitchFamily="18" charset="0"/>
-              </a:rPr>
-              <a:t>g</a:t>
-            </a:r>
-            <a:r>
-              <a:rPr lang="en-US" sz="3600" b="1" dirty="0">
-                <a:solidFill>
-                  <a:schemeClr val="tx1"/>
-                </a:solidFill>
-                <a:latin typeface="+mn-lt"/>
-                <a:cs typeface="Times New Roman" panose="02020603050405020304" pitchFamily="18" charset="0"/>
-              </a:rPr>
-              <a:t>it checkout &lt;your branch&gt;</a:t>
-            </a:r>
-            <a:endParaRPr lang="ru-RU" sz="3600" b="1" dirty="0">
-              <a:solidFill>
-                <a:schemeClr val="tx1"/>
-              </a:solidFill>
-              <a:latin typeface="+mn-lt"/>
-              <a:cs typeface="Times New Roman" panose="02020603050405020304" pitchFamily="18" charset="0"/>
-            </a:endParaRPr>
-          </a:p>
-          <a:p>
-            <a:pPr marL="0" indent="0">
-              <a:buNone/>
-            </a:pPr>
-            <a:r>
-              <a:rPr lang="ru-RU" sz="3600" dirty="0">
-                <a:solidFill>
-                  <a:schemeClr val="tx1"/>
-                </a:solidFill>
-                <a:effectLst/>
-                <a:latin typeface="+mn-lt"/>
-                <a:cs typeface="Times New Roman" panose="02020603050405020304" pitchFamily="18" charset="0"/>
-              </a:rPr>
-              <a:t>Перемещает вас в указанную после </a:t>
-            </a:r>
-            <a:r>
-              <a:rPr lang="en" sz="3600" dirty="0">
-                <a:solidFill>
-                  <a:schemeClr val="tx1"/>
-                </a:solidFill>
-                <a:effectLst/>
-                <a:latin typeface="+mn-lt"/>
-                <a:cs typeface="Times New Roman" panose="02020603050405020304" pitchFamily="18" charset="0"/>
-              </a:rPr>
-              <a:t>checkout </a:t>
-            </a:r>
-            <a:r>
-              <a:rPr lang="ru-RU" sz="3600" dirty="0">
-                <a:solidFill>
-                  <a:schemeClr val="tx1"/>
-                </a:solidFill>
-                <a:effectLst/>
-                <a:latin typeface="+mn-lt"/>
-                <a:cs typeface="Times New Roman" panose="02020603050405020304" pitchFamily="18" charset="0"/>
-              </a:rPr>
-              <a:t>ветвь </a:t>
-            </a:r>
-            <a:endParaRPr lang="ru-RU" sz="3600" b="1" dirty="0">
+            <a:endParaRPr lang="ru-RU" sz="2000" dirty="0">
               <a:solidFill>
                 <a:schemeClr val="tx1"/>
               </a:solidFill>
               <a:effectLst/>
               <a:latin typeface="+mn-lt"/>
-              <a:cs typeface="Times New Roman" panose="02020603050405020304" pitchFamily="18" charset="0"/>
-            </a:endParaRPr>
-          </a:p>
-          <a:p>
-            <a:pPr marL="0" indent="0">
-              <a:buNone/>
-            </a:pPr>
-            <a:endParaRPr lang="en-US" sz="3600" dirty="0">
-              <a:solidFill>
-                <a:schemeClr val="tx1"/>
-              </a:solidFill>
-              <a:effectLst/>
-              <a:latin typeface="+mn-lt"/>
-              <a:cs typeface="Times New Roman" panose="02020603050405020304" pitchFamily="18" charset="0"/>
-            </a:endParaRPr>
-          </a:p>
-          <a:p>
-            <a:pPr marL="0" indent="0">
-              <a:buNone/>
-            </a:pPr>
-            <a:r>
-              <a:rPr lang="en" sz="3600" b="1" dirty="0">
-                <a:solidFill>
-                  <a:schemeClr val="tx1"/>
-                </a:solidFill>
-                <a:effectLst/>
-                <a:latin typeface="+mn-lt"/>
-                <a:cs typeface="Times New Roman" panose="02020603050405020304" pitchFamily="18" charset="0"/>
-              </a:rPr>
-              <a:t>git add</a:t>
-            </a:r>
-            <a:endParaRPr lang="ru-RU" sz="3600" b="1" dirty="0">
-              <a:solidFill>
-                <a:schemeClr val="tx1"/>
-              </a:solidFill>
-              <a:effectLst/>
-              <a:latin typeface="+mn-lt"/>
-              <a:cs typeface="Times New Roman" panose="02020603050405020304" pitchFamily="18" charset="0"/>
-            </a:endParaRPr>
-          </a:p>
-          <a:p>
-            <a:pPr marL="0" indent="0">
-              <a:buNone/>
-            </a:pPr>
-            <a:r>
-              <a:rPr lang="ru-RU" sz="3600" dirty="0">
-                <a:solidFill>
-                  <a:schemeClr val="tx1"/>
-                </a:solidFill>
-                <a:effectLst/>
-                <a:latin typeface="+mn-lt"/>
-                <a:cs typeface="Times New Roman" panose="02020603050405020304" pitchFamily="18" charset="0"/>
-              </a:rPr>
-              <a:t>Добавляет </a:t>
-            </a:r>
-            <a:r>
-              <a:rPr lang="ru-RU" sz="3600" dirty="0" err="1">
-                <a:solidFill>
-                  <a:schemeClr val="tx1"/>
-                </a:solidFill>
-                <a:effectLst/>
-                <a:latin typeface="+mn-lt"/>
-                <a:cs typeface="Times New Roman" panose="02020603050405020304" pitchFamily="18" charset="0"/>
-              </a:rPr>
-              <a:t>файл</a:t>
-            </a:r>
-            <a:r>
-              <a:rPr lang="ru-RU" sz="3600" dirty="0">
-                <a:solidFill>
-                  <a:schemeClr val="tx1"/>
-                </a:solidFill>
-                <a:effectLst/>
-                <a:latin typeface="+mn-lt"/>
-                <a:cs typeface="Times New Roman" panose="02020603050405020304" pitchFamily="18" charset="0"/>
-              </a:rPr>
-              <a:t>, </a:t>
-            </a:r>
-            <a:r>
-              <a:rPr lang="ru-RU" sz="3600" dirty="0" err="1">
-                <a:solidFill>
-                  <a:schemeClr val="tx1"/>
-                </a:solidFill>
-                <a:effectLst/>
-                <a:latin typeface="+mn-lt"/>
-                <a:cs typeface="Times New Roman" panose="02020603050405020304" pitchFamily="18" charset="0"/>
-              </a:rPr>
-              <a:t>указанныи</a:t>
-            </a:r>
-            <a:r>
-              <a:rPr lang="ru-RU" sz="3600" dirty="0">
-                <a:solidFill>
-                  <a:schemeClr val="tx1"/>
-                </a:solidFill>
-                <a:effectLst/>
-                <a:latin typeface="+mn-lt"/>
-                <a:cs typeface="Times New Roman" panose="02020603050405020304" pitchFamily="18" charset="0"/>
-              </a:rPr>
-              <a:t>̆ после </a:t>
-            </a:r>
-            <a:r>
-              <a:rPr lang="en" sz="3600" dirty="0">
-                <a:solidFill>
-                  <a:schemeClr val="tx1"/>
-                </a:solidFill>
-                <a:effectLst/>
-                <a:latin typeface="+mn-lt"/>
-                <a:cs typeface="Times New Roman" panose="02020603050405020304" pitchFamily="18" charset="0"/>
-              </a:rPr>
-              <a:t>add, </a:t>
-            </a:r>
-            <a:r>
-              <a:rPr lang="ru-RU" sz="3600" dirty="0">
-                <a:solidFill>
-                  <a:schemeClr val="tx1"/>
-                </a:solidFill>
-                <a:effectLst/>
-                <a:latin typeface="+mn-lt"/>
-                <a:cs typeface="Times New Roman" panose="02020603050405020304" pitchFamily="18" charset="0"/>
-              </a:rPr>
-              <a:t>в рассмотрение на </a:t>
-            </a:r>
-            <a:r>
-              <a:rPr lang="ru-RU" sz="3600" dirty="0" err="1">
-                <a:solidFill>
-                  <a:schemeClr val="tx1"/>
-                </a:solidFill>
-                <a:effectLst/>
-                <a:latin typeface="+mn-lt"/>
-                <a:cs typeface="Times New Roman" panose="02020603050405020304" pitchFamily="18" charset="0"/>
-              </a:rPr>
-              <a:t>коммит</a:t>
-            </a:r>
-            <a:r>
-              <a:rPr lang="ru-RU" sz="3600" dirty="0">
-                <a:solidFill>
-                  <a:schemeClr val="tx1"/>
-                </a:solidFill>
-                <a:effectLst/>
-                <a:latin typeface="+mn-lt"/>
-                <a:cs typeface="Times New Roman" panose="02020603050405020304" pitchFamily="18" charset="0"/>
-              </a:rPr>
-              <a:t> </a:t>
-            </a:r>
-            <a:r>
-              <a:rPr lang="en-US" sz="3600" dirty="0">
-                <a:solidFill>
-                  <a:schemeClr val="tx1"/>
-                </a:solidFill>
-                <a:effectLst/>
-                <a:latin typeface="+mn-lt"/>
-                <a:cs typeface="Times New Roman" panose="02020603050405020304" pitchFamily="18" charset="0"/>
-              </a:rPr>
-              <a:t> (</a:t>
-            </a:r>
-            <a:r>
-              <a:rPr lang="en-US" sz="3600" dirty="0" err="1">
-                <a:solidFill>
-                  <a:schemeClr val="tx1"/>
-                </a:solidFill>
-                <a:effectLst/>
-                <a:latin typeface="+mn-lt"/>
-                <a:cs typeface="Times New Roman" panose="02020603050405020304" pitchFamily="18" charset="0"/>
-              </a:rPr>
-              <a:t>с</a:t>
-            </a:r>
-            <a:r>
-              <a:rPr lang="ru-RU" sz="3600" dirty="0" err="1">
-                <a:solidFill>
-                  <a:schemeClr val="tx1"/>
-                </a:solidFill>
-                <a:effectLst/>
-                <a:latin typeface="+mn-lt"/>
-                <a:cs typeface="Times New Roman" panose="02020603050405020304" pitchFamily="18" charset="0"/>
-              </a:rPr>
-              <a:t>имвол</a:t>
-            </a:r>
-            <a:r>
-              <a:rPr lang="ru-RU" sz="3600" dirty="0">
-                <a:solidFill>
-                  <a:schemeClr val="tx1"/>
-                </a:solidFill>
-                <a:effectLst/>
-                <a:latin typeface="+mn-lt"/>
-                <a:cs typeface="Times New Roman" panose="02020603050405020304" pitchFamily="18" charset="0"/>
-              </a:rPr>
-              <a:t> .</a:t>
-            </a:r>
-            <a:r>
-              <a:rPr lang="en-US" sz="3600" dirty="0">
-                <a:solidFill>
-                  <a:schemeClr val="tx1"/>
-                </a:solidFill>
-                <a:effectLst/>
-                <a:latin typeface="+mn-lt"/>
-                <a:cs typeface="Times New Roman" panose="02020603050405020304" pitchFamily="18" charset="0"/>
-              </a:rPr>
-              <a:t> </a:t>
-            </a:r>
-            <a:r>
-              <a:rPr lang="ru-RU" sz="3600" dirty="0">
-                <a:solidFill>
-                  <a:schemeClr val="tx1"/>
-                </a:solidFill>
-                <a:effectLst/>
-                <a:latin typeface="+mn-lt"/>
-                <a:cs typeface="Times New Roman" panose="02020603050405020304" pitchFamily="18" charset="0"/>
-              </a:rPr>
-              <a:t>Добавляет все измененные файлы)</a:t>
-            </a:r>
-          </a:p>
-          <a:p>
-            <a:pPr marL="0" indent="0">
-              <a:buNone/>
-            </a:pPr>
-            <a:endParaRPr lang="ru-RU" sz="3600" dirty="0">
-              <a:solidFill>
-                <a:schemeClr val="tx1"/>
-              </a:solidFill>
-              <a:latin typeface="+mn-lt"/>
-              <a:ea typeface="Tahoma" panose="020B0604030504040204" pitchFamily="34" charset="0"/>
-              <a:cs typeface="Times New Roman" panose="02020603050405020304" pitchFamily="18" charset="0"/>
             </a:endParaRPr>
           </a:p>
         </p:txBody>
@@ -16209,7 +15965,7 @@
     </p:spTree>
     <p:extLst>
       <p:ext uri="{BB962C8B-B14F-4D97-AF65-F5344CB8AC3E}">
-        <p14:creationId xmlns:p14="http://schemas.microsoft.com/office/powerpoint/2010/main" val="571222784"/>
+        <p14:creationId xmlns:p14="http://schemas.microsoft.com/office/powerpoint/2010/main" val="1326201710"/>
       </p:ext>
     </p:extLst>
   </p:cSld>

</xml_diff>